<commit_message>
scensim: Scenario Brief template refinements (concurrent session)
Continued iteration on the Scenario Brief PowerPoint template feature
(596ec673): a paragraph-level font-size fix in render-pptx-html.py so a
short run smaller than its shape's default no longer inherits the larger
container line-height and gets clipped; wizard copy tightened to cap the
arc at one roleplay/observe step; regenerated preview images and example
PPTX outputs; build-scenario-brief.py simplified; cache-bust bumps on the
wizard include.

Co-Authored-By: Claude Sonnet 5 <noreply@anthropic.com>
</commit_message>
<xml_diff>
--- a/products/aithera/scenario-simulator/docs/templates/scenario-brief-example-marshall.pptx
+++ b/products/aithera/scenario-simulator/docs/templates/scenario-brief-example-marshall.pptx
@@ -523,7 +523,7 @@
           <a:p/>
           <a:p>
             <a:r>
-              <a:t>One slide per step: duplicate a STEP slide (Cmd/Ctrl+D) for each new step rather than inserting from the layout gallery. Delete THE OPENING if the scenario has no warm-up. Delete EXAMPLES slides you don’t need — the wizard drafts examples itself.</a:t>
+              <a:t>One slide per step: duplicate a STEP slide (Cmd/Ctrl+D) for each new step rather than inserting from the layout gallery. Delete INITIAL REFLECTION if the scenario has no warm-up. Delete EXAMPLES slides you don’t need — the wizard drafts examples itself.</a:t>
             </a:r>
           </a:p>
           <a:p/>
@@ -586,7 +586,7 @@
         <p:spPr>
           <a:xfrm>
             <a:off x="457200" y="1097280"/>
-            <a:ext cx="7040880" cy="1371600"/>
+            <a:ext cx="7040880" cy="4663440"/>
           </a:xfrm>
           <a:prstGeom prst="roundRect">
             <a:avLst>
@@ -629,8 +629,8 @@
         </p:nvSpPr>
         <p:spPr>
           <a:xfrm>
-            <a:off x="457200" y="2651760"/>
-            <a:ext cx="7040880" cy="914400"/>
+            <a:off x="8881567" y="384048"/>
+            <a:ext cx="2852928" cy="329184"/>
           </a:xfrm>
           <a:prstGeom prst="roundRect">
             <a:avLst>
@@ -638,7 +638,7 @@
             </a:avLst>
           </a:prstGeom>
           <a:solidFill>
-            <a:srgbClr val="EEF4FB"/>
+            <a:srgbClr val="E3ECF7"/>
           </a:solidFill>
           <a:ln>
             <a:noFill/>
@@ -667,14 +667,159 @@
       </p:sp>
       <p:sp>
         <p:nvSpPr>
-          <p:cNvPr id="5" name="panel"/>
+          <p:cNvPr id="5" name="chip"/>
+          <p:cNvSpPr txBox="1"/>
+          <p:nvPr/>
+        </p:nvSpPr>
+        <p:spPr>
+          <a:xfrm>
+            <a:off x="8881567" y="384048"/>
+            <a:ext cx="2852928" cy="329184"/>
+          </a:xfrm>
+          <a:prstGeom prst="rect">
+            <a:avLst/>
+          </a:prstGeom>
+          <a:noFill/>
+        </p:spPr>
+        <p:txBody>
+          <a:bodyPr wrap="square" lIns="109728" rIns="109728" tIns="27432" bIns="27432" anchor="ctr">
+            <a:spAutoFit/>
+          </a:bodyPr>
+          <a:lstStyle/>
+          <a:p>
+            <a:r>
+              <a:rPr sz="900" b="0" i="0">
+                <a:solidFill>
+                  <a:srgbClr val="43505E"/>
+                </a:solidFill>
+                <a:latin typeface="Calibri"/>
+              </a:rPr>
+              <a:t>Cover  →  editor: Basics · Title</a:t>
+            </a:r>
+          </a:p>
+        </p:txBody>
+      </p:sp>
+      <p:sp>
+        <p:nvSpPr>
+          <p:cNvPr id="6" name="help"/>
+          <p:cNvSpPr txBox="1"/>
+          <p:nvPr/>
+        </p:nvSpPr>
+        <p:spPr>
+          <a:xfrm>
+            <a:off x="457200" y="5486400"/>
+            <a:ext cx="7040880" cy="274320"/>
+          </a:xfrm>
+          <a:prstGeom prst="rect">
+            <a:avLst/>
+          </a:prstGeom>
+          <a:noFill/>
+        </p:spPr>
+        <p:txBody>
+          <a:bodyPr wrap="square" lIns="109728" rIns="109728" tIns="27432" bIns="27432" anchor="ctr">
+            <a:spAutoFit/>
+          </a:bodyPr>
+          <a:lstStyle/>
+          <a:p>
+            <a:r>
+              <a:rPr sz="750" b="0" i="1">
+                <a:solidFill>
+                  <a:srgbClr val="6B7785"/>
+                </a:solidFill>
+                <a:latin typeface="Calibri"/>
+              </a:rPr>
+              <a:t>Working title — the draft proposes one if blank.  → editor: Basics · Title</a:t>
+            </a:r>
+          </a:p>
+        </p:txBody>
+      </p:sp>
+      <p:sp>
+        <p:nvSpPr>
+          <p:cNvPr id="7" name="footer"/>
+          <p:cNvSpPr txBox="1"/>
+          <p:nvPr/>
+        </p:nvSpPr>
+        <p:spPr>
+          <a:xfrm>
+            <a:off x="457200" y="6510528"/>
+            <a:ext cx="5943600" cy="274320"/>
+          </a:xfrm>
+          <a:prstGeom prst="rect">
+            <a:avLst/>
+          </a:prstGeom>
+          <a:noFill/>
+        </p:spPr>
+        <p:txBody>
+          <a:bodyPr wrap="square" lIns="109728" rIns="109728" tIns="27432" bIns="27432" anchor="t">
+            <a:spAutoFit/>
+          </a:bodyPr>
+          <a:lstStyle/>
+          <a:p>
+            <a:r>
+              <a:rPr sz="800" b="1" i="0">
+                <a:solidFill>
+                  <a:srgbClr val="6B7785"/>
+                </a:solidFill>
+                <a:latin typeface="Calibri"/>
+              </a:rPr>
+              <a:t>Scenario Brief · template v1</a:t>
+            </a:r>
+            <a:r>
+              <a:rPr sz="800" b="0" i="0">
+                <a:solidFill>
+                  <a:srgbClr val="6B7785"/>
+                </a:solidFill>
+                <a:latin typeface="Calibri"/>
+              </a:rPr>
+              <a:t>  ·  Aithera Scenario Simulator</a:t>
+            </a:r>
+          </a:p>
+        </p:txBody>
+      </p:sp>
+      <p:sp>
+        <p:nvSpPr>
+          <p:cNvPr id="8" name="footer"/>
+          <p:cNvSpPr txBox="1"/>
+          <p:nvPr/>
+        </p:nvSpPr>
+        <p:spPr>
+          <a:xfrm>
+            <a:off x="6309360" y="6510528"/>
+            <a:ext cx="5422392" cy="274320"/>
+          </a:xfrm>
+          <a:prstGeom prst="rect">
+            <a:avLst/>
+          </a:prstGeom>
+          <a:noFill/>
+        </p:spPr>
+        <p:txBody>
+          <a:bodyPr wrap="square" lIns="109728" rIns="109728" tIns="27432" bIns="27432" anchor="t">
+            <a:spAutoFit/>
+          </a:bodyPr>
+          <a:lstStyle/>
+          <a:p>
+            <a:r>
+              <a:rPr sz="800" b="0" i="1">
+                <a:solidFill>
+                  <a:srgbClr val="6B7785"/>
+                </a:solidFill>
+                <a:latin typeface="Calibri"/>
+              </a:rPr>
+              <a:t>Fields are placeholders — type into them. Text boxes and tables are not exported.</a:t>
+            </a:r>
+          </a:p>
+        </p:txBody>
+      </p:sp>
+      <p:sp>
+        <p:nvSpPr>
+          <p:cNvPr id="9" name="panel"/>
           <p:cNvSpPr/>
           <p:nvPr/>
         </p:nvSpPr>
         <p:spPr>
           <a:xfrm>
-            <a:off x="457200" y="3749039"/>
-            <a:ext cx="3383280" cy="914400"/>
+            <a:off x="7863840" y="1097280"/>
+            <a:ext cx="3867912" cy="4663440"/>
           </a:xfrm>
           <a:prstGeom prst="roundRect">
             <a:avLst>
@@ -682,7 +827,7 @@
             </a:avLst>
           </a:prstGeom>
           <a:solidFill>
-            <a:srgbClr val="EEF4FB"/>
+            <a:srgbClr val="E3ECF7"/>
           </a:solidFill>
           <a:ln>
             <a:noFill/>
@@ -711,464 +856,7 @@
       </p:sp>
       <p:sp>
         <p:nvSpPr>
-          <p:cNvPr id="6" name="panel"/>
-          <p:cNvSpPr/>
-          <p:nvPr/>
-        </p:nvSpPr>
-        <p:spPr>
-          <a:xfrm>
-            <a:off x="4114800" y="3749039"/>
-            <a:ext cx="3383280" cy="914400"/>
-          </a:xfrm>
-          <a:prstGeom prst="roundRect">
-            <a:avLst>
-              <a:gd name="adj" fmla="val 4500"/>
-            </a:avLst>
-          </a:prstGeom>
-          <a:solidFill>
-            <a:srgbClr val="EEF4FB"/>
-          </a:solidFill>
-          <a:ln>
-            <a:noFill/>
-          </a:ln>
-          <a:effectLst/>
-        </p:spPr>
-        <p:style>
-          <a:lnRef idx="1">
-            <a:schemeClr val="accent1"/>
-          </a:lnRef>
-          <a:fillRef idx="3">
-            <a:schemeClr val="accent1"/>
-          </a:fillRef>
-          <a:effectRef idx="2">
-            <a:schemeClr val="accent1"/>
-          </a:effectRef>
-          <a:fontRef idx="minor">
-            <a:schemeClr val="lt1"/>
-          </a:fontRef>
-        </p:style>
-        <p:txBody>
-          <a:bodyPr rtlCol="0" anchor="ctr"/>
-          <a:lstStyle/>
-          <a:p/>
-        </p:txBody>
-      </p:sp>
-      <p:sp>
-        <p:nvSpPr>
-          <p:cNvPr id="7" name="panel"/>
-          <p:cNvSpPr/>
-          <p:nvPr/>
-        </p:nvSpPr>
-        <p:spPr>
-          <a:xfrm>
-            <a:off x="457200" y="4846320"/>
-            <a:ext cx="7040880" cy="914400"/>
-          </a:xfrm>
-          <a:prstGeom prst="roundRect">
-            <a:avLst>
-              <a:gd name="adj" fmla="val 4500"/>
-            </a:avLst>
-          </a:prstGeom>
-          <a:solidFill>
-            <a:srgbClr val="EEF4FB"/>
-          </a:solidFill>
-          <a:ln>
-            <a:noFill/>
-          </a:ln>
-          <a:effectLst/>
-        </p:spPr>
-        <p:style>
-          <a:lnRef idx="1">
-            <a:schemeClr val="accent1"/>
-          </a:lnRef>
-          <a:fillRef idx="3">
-            <a:schemeClr val="accent1"/>
-          </a:fillRef>
-          <a:effectRef idx="2">
-            <a:schemeClr val="accent1"/>
-          </a:effectRef>
-          <a:fontRef idx="minor">
-            <a:schemeClr val="lt1"/>
-          </a:fontRef>
-        </p:style>
-        <p:txBody>
-          <a:bodyPr rtlCol="0" anchor="ctr"/>
-          <a:lstStyle/>
-          <a:p/>
-        </p:txBody>
-      </p:sp>
-      <p:sp>
-        <p:nvSpPr>
-          <p:cNvPr id="8" name="panel"/>
-          <p:cNvSpPr/>
-          <p:nvPr/>
-        </p:nvSpPr>
-        <p:spPr>
-          <a:xfrm>
-            <a:off x="7948879" y="384048"/>
-            <a:ext cx="3785616" cy="329184"/>
-          </a:xfrm>
-          <a:prstGeom prst="roundRect">
-            <a:avLst>
-              <a:gd name="adj" fmla="val 4500"/>
-            </a:avLst>
-          </a:prstGeom>
-          <a:solidFill>
-            <a:srgbClr val="E3ECF7"/>
-          </a:solidFill>
-          <a:ln>
-            <a:noFill/>
-          </a:ln>
-          <a:effectLst/>
-        </p:spPr>
-        <p:style>
-          <a:lnRef idx="1">
-            <a:schemeClr val="accent1"/>
-          </a:lnRef>
-          <a:fillRef idx="3">
-            <a:schemeClr val="accent1"/>
-          </a:fillRef>
-          <a:effectRef idx="2">
-            <a:schemeClr val="accent1"/>
-          </a:effectRef>
-          <a:fontRef idx="minor">
-            <a:schemeClr val="lt1"/>
-          </a:fontRef>
-        </p:style>
-        <p:txBody>
-          <a:bodyPr rtlCol="0" anchor="ctr"/>
-          <a:lstStyle/>
-          <a:p/>
-        </p:txBody>
-      </p:sp>
-      <p:sp>
-        <p:nvSpPr>
-          <p:cNvPr id="9" name="chip"/>
-          <p:cNvSpPr txBox="1"/>
-          <p:nvPr/>
-        </p:nvSpPr>
-        <p:spPr>
-          <a:xfrm>
-            <a:off x="7948879" y="384048"/>
-            <a:ext cx="3785616" cy="329184"/>
-          </a:xfrm>
-          <a:prstGeom prst="rect">
-            <a:avLst/>
-          </a:prstGeom>
-          <a:noFill/>
-        </p:spPr>
-        <p:txBody>
-          <a:bodyPr wrap="square" lIns="109728" rIns="109728" tIns="27432" bIns="27432" anchor="ctr">
-            <a:spAutoFit/>
-          </a:bodyPr>
-          <a:lstStyle/>
-          <a:p>
-            <a:r>
-              <a:rPr sz="900" b="0" i="0">
-                <a:solidFill>
-                  <a:srgbClr val="43505E"/>
-                </a:solidFill>
-                <a:latin typeface="Calibri"/>
-              </a:rPr>
-              <a:t>Cover · the team’s own record — not imported</a:t>
-            </a:r>
-          </a:p>
-        </p:txBody>
-      </p:sp>
-      <p:sp>
-        <p:nvSpPr>
-          <p:cNvPr id="10" name="help"/>
-          <p:cNvSpPr txBox="1"/>
-          <p:nvPr/>
-        </p:nvSpPr>
-        <p:spPr>
-          <a:xfrm>
-            <a:off x="457200" y="2194560"/>
-            <a:ext cx="7040880" cy="274320"/>
-          </a:xfrm>
-          <a:prstGeom prst="rect">
-            <a:avLst/>
-          </a:prstGeom>
-          <a:noFill/>
-        </p:spPr>
-        <p:txBody>
-          <a:bodyPr wrap="square" lIns="109728" rIns="109728" tIns="27432" bIns="27432" anchor="ctr">
-            <a:spAutoFit/>
-          </a:bodyPr>
-          <a:lstStyle/>
-          <a:p>
-            <a:r>
-              <a:rPr sz="750" b="0" i="1">
-                <a:solidFill>
-                  <a:srgbClr val="6B7785"/>
-                </a:solidFill>
-                <a:latin typeface="Calibri"/>
-              </a:rPr>
-              <a:t>Working title — the draft proposes one if blank.  → editor: Basics · Title</a:t>
-            </a:r>
-          </a:p>
-        </p:txBody>
-      </p:sp>
-      <p:sp>
-        <p:nvSpPr>
-          <p:cNvPr id="11" name="help"/>
-          <p:cNvSpPr txBox="1"/>
-          <p:nvPr/>
-        </p:nvSpPr>
-        <p:spPr>
-          <a:xfrm>
-            <a:off x="457200" y="3291840"/>
-            <a:ext cx="7040880" cy="274320"/>
-          </a:xfrm>
-          <a:prstGeom prst="rect">
-            <a:avLst/>
-          </a:prstGeom>
-          <a:noFill/>
-        </p:spPr>
-        <p:txBody>
-          <a:bodyPr wrap="square" lIns="109728" rIns="109728" tIns="27432" bIns="27432" anchor="ctr">
-            <a:spAutoFit/>
-          </a:bodyPr>
-          <a:lstStyle/>
-          <a:p>
-            <a:r>
-              <a:rPr sz="750" b="0" i="1">
-                <a:solidFill>
-                  <a:srgbClr val="6B7785"/>
-                </a:solidFill>
-                <a:latin typeface="Calibri"/>
-              </a:rPr>
-              <a:t>The course or program, with its code. Sets the register.  → wizard: The training it lives inside</a:t>
-            </a:r>
-          </a:p>
-        </p:txBody>
-      </p:sp>
-      <p:sp>
-        <p:nvSpPr>
-          <p:cNvPr id="12" name="help"/>
-          <p:cNvSpPr txBox="1"/>
-          <p:nvPr/>
-        </p:nvSpPr>
-        <p:spPr>
-          <a:xfrm>
-            <a:off x="457200" y="4389120"/>
-            <a:ext cx="3383280" cy="274320"/>
-          </a:xfrm>
-          <a:prstGeom prst="rect">
-            <a:avLst/>
-          </a:prstGeom>
-          <a:noFill/>
-        </p:spPr>
-        <p:txBody>
-          <a:bodyPr wrap="square" lIns="109728" rIns="109728" tIns="27432" bIns="27432" anchor="ctr">
-            <a:spAutoFit/>
-          </a:bodyPr>
-          <a:lstStyle/>
-          <a:p>
-            <a:r>
-              <a:rPr sz="750" b="0" i="1">
-                <a:solidFill>
-                  <a:srgbClr val="6B7785"/>
-                </a:solidFill>
-                <a:latin typeface="Calibri"/>
-              </a:rPr>
-              <a:t>Who to ask about this brief.</a:t>
-            </a:r>
-          </a:p>
-        </p:txBody>
-      </p:sp>
-      <p:sp>
-        <p:nvSpPr>
-          <p:cNvPr id="13" name="help"/>
-          <p:cNvSpPr txBox="1"/>
-          <p:nvPr/>
-        </p:nvSpPr>
-        <p:spPr>
-          <a:xfrm>
-            <a:off x="4114800" y="4389120"/>
-            <a:ext cx="3383280" cy="274320"/>
-          </a:xfrm>
-          <a:prstGeom prst="rect">
-            <a:avLst/>
-          </a:prstGeom>
-          <a:noFill/>
-        </p:spPr>
-        <p:txBody>
-          <a:bodyPr wrap="square" lIns="109728" rIns="109728" tIns="27432" bIns="27432" anchor="ctr">
-            <a:spAutoFit/>
-          </a:bodyPr>
-          <a:lstStyle/>
-          <a:p>
-            <a:r>
-              <a:rPr sz="750" b="0" i="1">
-                <a:solidFill>
-                  <a:srgbClr val="6B7785"/>
-                </a:solidFill>
-                <a:latin typeface="Calibri"/>
-              </a:rPr>
-              <a:t>Your own versioning. PowerPoint keeps the history.</a:t>
-            </a:r>
-          </a:p>
-        </p:txBody>
-      </p:sp>
-      <p:sp>
-        <p:nvSpPr>
-          <p:cNvPr id="14" name="help"/>
-          <p:cNvSpPr txBox="1"/>
-          <p:nvPr/>
-        </p:nvSpPr>
-        <p:spPr>
-          <a:xfrm>
-            <a:off x="457200" y="5486400"/>
-            <a:ext cx="7040880" cy="274320"/>
-          </a:xfrm>
-          <a:prstGeom prst="rect">
-            <a:avLst/>
-          </a:prstGeom>
-          <a:noFill/>
-        </p:spPr>
-        <p:txBody>
-          <a:bodyPr wrap="square" lIns="109728" rIns="109728" tIns="27432" bIns="27432" anchor="ctr">
-            <a:spAutoFit/>
-          </a:bodyPr>
-          <a:lstStyle/>
-          <a:p>
-            <a:r>
-              <a:rPr sz="750" b="0" i="1">
-                <a:solidFill>
-                  <a:srgbClr val="6B7785"/>
-                </a:solidFill>
-                <a:latin typeface="Calibri"/>
-              </a:rPr>
-              <a:t>Draft · SME review · Ready for the editor · Drafted in the editor</a:t>
-            </a:r>
-          </a:p>
-        </p:txBody>
-      </p:sp>
-      <p:sp>
-        <p:nvSpPr>
-          <p:cNvPr id="15" name="footer"/>
-          <p:cNvSpPr txBox="1"/>
-          <p:nvPr/>
-        </p:nvSpPr>
-        <p:spPr>
-          <a:xfrm>
-            <a:off x="457200" y="6510528"/>
-            <a:ext cx="5943600" cy="274320"/>
-          </a:xfrm>
-          <a:prstGeom prst="rect">
-            <a:avLst/>
-          </a:prstGeom>
-          <a:noFill/>
-        </p:spPr>
-        <p:txBody>
-          <a:bodyPr wrap="square" lIns="109728" rIns="109728" tIns="27432" bIns="27432" anchor="t">
-            <a:spAutoFit/>
-          </a:bodyPr>
-          <a:lstStyle/>
-          <a:p>
-            <a:r>
-              <a:rPr sz="800" b="1" i="0">
-                <a:solidFill>
-                  <a:srgbClr val="6B7785"/>
-                </a:solidFill>
-                <a:latin typeface="Calibri"/>
-              </a:rPr>
-              <a:t>Scenario Brief · template v1</a:t>
-            </a:r>
-            <a:r>
-              <a:rPr sz="800" b="0" i="0">
-                <a:solidFill>
-                  <a:srgbClr val="6B7785"/>
-                </a:solidFill>
-                <a:latin typeface="Calibri"/>
-              </a:rPr>
-              <a:t>  ·  Aithera Scenario Simulator</a:t>
-            </a:r>
-          </a:p>
-        </p:txBody>
-      </p:sp>
-      <p:sp>
-        <p:nvSpPr>
-          <p:cNvPr id="16" name="footer"/>
-          <p:cNvSpPr txBox="1"/>
-          <p:nvPr/>
-        </p:nvSpPr>
-        <p:spPr>
-          <a:xfrm>
-            <a:off x="6309360" y="6510528"/>
-            <a:ext cx="5422392" cy="274320"/>
-          </a:xfrm>
-          <a:prstGeom prst="rect">
-            <a:avLst/>
-          </a:prstGeom>
-          <a:noFill/>
-        </p:spPr>
-        <p:txBody>
-          <a:bodyPr wrap="square" lIns="109728" rIns="109728" tIns="27432" bIns="27432" anchor="t">
-            <a:spAutoFit/>
-          </a:bodyPr>
-          <a:lstStyle/>
-          <a:p>
-            <a:r>
-              <a:rPr sz="800" b="0" i="1">
-                <a:solidFill>
-                  <a:srgbClr val="6B7785"/>
-                </a:solidFill>
-                <a:latin typeface="Calibri"/>
-              </a:rPr>
-              <a:t>Fields are placeholders — type into them. Text boxes and tables are not exported.</a:t>
-            </a:r>
-          </a:p>
-        </p:txBody>
-      </p:sp>
-      <p:sp>
-        <p:nvSpPr>
-          <p:cNvPr id="17" name="panel"/>
-          <p:cNvSpPr/>
-          <p:nvPr/>
-        </p:nvSpPr>
-        <p:spPr>
-          <a:xfrm>
-            <a:off x="7863840" y="1097280"/>
-            <a:ext cx="3867912" cy="4663440"/>
-          </a:xfrm>
-          <a:prstGeom prst="roundRect">
-            <a:avLst>
-              <a:gd name="adj" fmla="val 4500"/>
-            </a:avLst>
-          </a:prstGeom>
-          <a:solidFill>
-            <a:srgbClr val="E3ECF7"/>
-          </a:solidFill>
-          <a:ln>
-            <a:noFill/>
-          </a:ln>
-          <a:effectLst/>
-        </p:spPr>
-        <p:style>
-          <a:lnRef idx="1">
-            <a:schemeClr val="accent1"/>
-          </a:lnRef>
-          <a:fillRef idx="3">
-            <a:schemeClr val="accent1"/>
-          </a:fillRef>
-          <a:effectRef idx="2">
-            <a:schemeClr val="accent1"/>
-          </a:effectRef>
-          <a:fontRef idx="minor">
-            <a:schemeClr val="lt1"/>
-          </a:fontRef>
-        </p:style>
-        <p:txBody>
-          <a:bodyPr rtlCol="0" anchor="ctr"/>
-          <a:lstStyle/>
-          <a:p/>
-        </p:txBody>
-      </p:sp>
-      <p:sp>
-        <p:nvSpPr>
-          <p:cNvPr id="18" name="howto"/>
+          <p:cNvPr id="10" name="howto"/>
           <p:cNvSpPr txBox="1"/>
           <p:nvPr/>
         </p:nvSpPr>
@@ -1377,7 +1065,7 @@
       </p:sp>
       <p:sp>
         <p:nvSpPr>
-          <p:cNvPr id="19" name="title"/>
+          <p:cNvPr id="11" name="title"/>
           <p:cNvSpPr/>
           <p:nvPr>
             <p:ph type="title"/>
@@ -1386,7 +1074,7 @@
         <p:spPr>
           <a:xfrm>
             <a:off x="457200" y="274320"/>
-            <a:ext cx="7308799" cy="640080"/>
+            <a:ext cx="8241487" cy="640080"/>
           </a:xfrm>
           <a:prstGeom prst="rect">
             <a:avLst/>
@@ -1419,14 +1107,14 @@
                 </a:solidFill>
                 <a:latin typeface="Calibri"/>
               </a:rPr>
-              <a:t>SCENARIO BRIEF</a:t>
-            </a:r>
-          </a:p>
-        </p:txBody>
-      </p:sp>
-      <p:sp>
-        <p:nvSpPr>
-          <p:cNvPr id="20" name="cover.title"/>
+              <a:t>SCENARIO BASICS</a:t>
+            </a:r>
+          </a:p>
+        </p:txBody>
+      </p:sp>
+      <p:sp>
+        <p:nvSpPr>
+          <p:cNvPr id="12" name="cover.title"/>
           <p:cNvSpPr/>
           <p:nvPr>
             <p:ph type="body" idx="10"/>
@@ -1435,7 +1123,7 @@
         <p:spPr>
           <a:xfrm>
             <a:off x="457200" y="1097280"/>
-            <a:ext cx="7040880" cy="1097280"/>
+            <a:ext cx="7040880" cy="4389120"/>
           </a:xfrm>
           <a:prstGeom prst="rect">
             <a:avLst/>
@@ -1480,270 +1168,6 @@
           <a:p>
             <a:r>
               <a:rPr sz="2400" b="0" i="1">
-                <a:solidFill>
-                  <a:srgbClr val="6B7785"/>
-                </a:solidFill>
-                <a:latin typeface="Calibri"/>
-              </a:rPr>
-              <a:t>Type here — keep the label line above.</a:t>
-            </a:r>
-          </a:p>
-        </p:txBody>
-      </p:sp>
-      <p:sp>
-        <p:nvSpPr>
-          <p:cNvPr id="21" name="cover.training"/>
-          <p:cNvSpPr/>
-          <p:nvPr>
-            <p:ph type="body" idx="11"/>
-          </p:nvPr>
-        </p:nvSpPr>
-        <p:spPr>
-          <a:xfrm>
-            <a:off x="457200" y="2651760"/>
-            <a:ext cx="7040880" cy="640080"/>
-          </a:xfrm>
-          <a:prstGeom prst="rect">
-            <a:avLst/>
-          </a:prstGeom>
-          <a:noFill/>
-        </p:spPr>
-        <p:txBody>
-          <a:bodyPr wrap="square" lIns="109728" rIns="109728" tIns="64008" anchor="t">
-            <a:normAutofit/>
-          </a:bodyPr>
-          <a:lstStyle>
-            <a:lvl1pPr marL="0" indent="0">
-              <a:spcBef>
-                <a:spcPts val="200"/>
-              </a:spcBef>
-              <a:buNone/>
-              <a:defRPr sz="1400" b="0">
-                <a:solidFill>
-                  <a:srgbClr val="1F2A37"/>
-                </a:solidFill>
-                <a:latin typeface="Calibri"/>
-              </a:defRPr>
-            </a:lvl1pPr>
-            <a:lvl2pPr marL="228600" indent="-228600">
-              <a:buChar char="•"/>
-              <a:defRPr sz="1400">
-                <a:latin typeface="Calibri"/>
-              </a:defRPr>
-            </a:lvl2pPr>
-          </a:lstStyle>
-          <a:p>
-            <a:r>
-              <a:rPr sz="900" b="1" i="0" spc="60">
-                <a:solidFill>
-                  <a:srgbClr val="0271CE"/>
-                </a:solidFill>
-                <a:latin typeface="Calibri"/>
-              </a:rPr>
-              <a:t>TRAINING IT LIVES INSIDE</a:t>
-            </a:r>
-          </a:p>
-          <a:p>
-            <a:r>
-              <a:rPr sz="1400" b="0" i="1">
-                <a:solidFill>
-                  <a:srgbClr val="6B7785"/>
-                </a:solidFill>
-                <a:latin typeface="Calibri"/>
-              </a:rPr>
-              <a:t>Type here — keep the label line above.</a:t>
-            </a:r>
-          </a:p>
-        </p:txBody>
-      </p:sp>
-      <p:sp>
-        <p:nvSpPr>
-          <p:cNvPr id="22" name="cover.owner"/>
-          <p:cNvSpPr/>
-          <p:nvPr>
-            <p:ph type="body" idx="12"/>
-          </p:nvPr>
-        </p:nvSpPr>
-        <p:spPr>
-          <a:xfrm>
-            <a:off x="457200" y="3749039"/>
-            <a:ext cx="3383280" cy="640080"/>
-          </a:xfrm>
-          <a:prstGeom prst="rect">
-            <a:avLst/>
-          </a:prstGeom>
-          <a:noFill/>
-        </p:spPr>
-        <p:txBody>
-          <a:bodyPr wrap="square" lIns="109728" rIns="109728" tIns="64008" anchor="t">
-            <a:normAutofit/>
-          </a:bodyPr>
-          <a:lstStyle>
-            <a:lvl1pPr marL="0" indent="0">
-              <a:spcBef>
-                <a:spcPts val="200"/>
-              </a:spcBef>
-              <a:buNone/>
-              <a:defRPr sz="1400" b="0">
-                <a:solidFill>
-                  <a:srgbClr val="1F2A37"/>
-                </a:solidFill>
-                <a:latin typeface="Calibri"/>
-              </a:defRPr>
-            </a:lvl1pPr>
-            <a:lvl2pPr marL="228600" indent="-228600">
-              <a:buChar char="•"/>
-              <a:defRPr sz="1400">
-                <a:latin typeface="Calibri"/>
-              </a:defRPr>
-            </a:lvl2pPr>
-          </a:lstStyle>
-          <a:p>
-            <a:r>
-              <a:rPr sz="900" b="1" i="0" spc="60">
-                <a:solidFill>
-                  <a:srgbClr val="0271CE"/>
-                </a:solidFill>
-                <a:latin typeface="Calibri"/>
-              </a:rPr>
-              <a:t>OWNER</a:t>
-            </a:r>
-          </a:p>
-          <a:p>
-            <a:r>
-              <a:rPr sz="1400" b="0" i="1">
-                <a:solidFill>
-                  <a:srgbClr val="6B7785"/>
-                </a:solidFill>
-                <a:latin typeface="Calibri"/>
-              </a:rPr>
-              <a:t>Type here — keep the label line above.</a:t>
-            </a:r>
-          </a:p>
-        </p:txBody>
-      </p:sp>
-      <p:sp>
-        <p:nvSpPr>
-          <p:cNvPr id="23" name="cover.version"/>
-          <p:cNvSpPr/>
-          <p:nvPr>
-            <p:ph type="body" idx="13"/>
-          </p:nvPr>
-        </p:nvSpPr>
-        <p:spPr>
-          <a:xfrm>
-            <a:off x="4114800" y="3749039"/>
-            <a:ext cx="3383280" cy="640080"/>
-          </a:xfrm>
-          <a:prstGeom prst="rect">
-            <a:avLst/>
-          </a:prstGeom>
-          <a:noFill/>
-        </p:spPr>
-        <p:txBody>
-          <a:bodyPr wrap="square" lIns="109728" rIns="109728" tIns="64008" anchor="t">
-            <a:normAutofit/>
-          </a:bodyPr>
-          <a:lstStyle>
-            <a:lvl1pPr marL="0" indent="0">
-              <a:spcBef>
-                <a:spcPts val="200"/>
-              </a:spcBef>
-              <a:buNone/>
-              <a:defRPr sz="1400" b="0">
-                <a:solidFill>
-                  <a:srgbClr val="1F2A37"/>
-                </a:solidFill>
-                <a:latin typeface="Calibri"/>
-              </a:defRPr>
-            </a:lvl1pPr>
-            <a:lvl2pPr marL="228600" indent="-228600">
-              <a:buChar char="•"/>
-              <a:defRPr sz="1400">
-                <a:latin typeface="Calibri"/>
-              </a:defRPr>
-            </a:lvl2pPr>
-          </a:lstStyle>
-          <a:p>
-            <a:r>
-              <a:rPr sz="900" b="1" i="0" spc="60">
-                <a:solidFill>
-                  <a:srgbClr val="0271CE"/>
-                </a:solidFill>
-                <a:latin typeface="Calibri"/>
-              </a:rPr>
-              <a:t>VERSION · DATE</a:t>
-            </a:r>
-          </a:p>
-          <a:p>
-            <a:r>
-              <a:rPr sz="1400" b="0" i="1">
-                <a:solidFill>
-                  <a:srgbClr val="6B7785"/>
-                </a:solidFill>
-                <a:latin typeface="Calibri"/>
-              </a:rPr>
-              <a:t>Type here — keep the label line above.</a:t>
-            </a:r>
-          </a:p>
-        </p:txBody>
-      </p:sp>
-      <p:sp>
-        <p:nvSpPr>
-          <p:cNvPr id="24" name="cover.status"/>
-          <p:cNvSpPr/>
-          <p:nvPr>
-            <p:ph type="body" idx="14"/>
-          </p:nvPr>
-        </p:nvSpPr>
-        <p:spPr>
-          <a:xfrm>
-            <a:off x="457200" y="4846320"/>
-            <a:ext cx="7040880" cy="640080"/>
-          </a:xfrm>
-          <a:prstGeom prst="rect">
-            <a:avLst/>
-          </a:prstGeom>
-          <a:noFill/>
-        </p:spPr>
-        <p:txBody>
-          <a:bodyPr wrap="square" lIns="109728" rIns="109728" tIns="64008" anchor="t">
-            <a:normAutofit/>
-          </a:bodyPr>
-          <a:lstStyle>
-            <a:lvl1pPr marL="0" indent="0">
-              <a:spcBef>
-                <a:spcPts val="200"/>
-              </a:spcBef>
-              <a:buNone/>
-              <a:defRPr sz="1400" b="0">
-                <a:solidFill>
-                  <a:srgbClr val="1F2A37"/>
-                </a:solidFill>
-                <a:latin typeface="Calibri"/>
-              </a:defRPr>
-            </a:lvl1pPr>
-            <a:lvl2pPr marL="228600" indent="-228600">
-              <a:buChar char="•"/>
-              <a:defRPr sz="1400">
-                <a:latin typeface="Calibri"/>
-              </a:defRPr>
-            </a:lvl2pPr>
-          </a:lstStyle>
-          <a:p>
-            <a:r>
-              <a:rPr sz="900" b="1" i="0" spc="60">
-                <a:solidFill>
-                  <a:srgbClr val="0271CE"/>
-                </a:solidFill>
-                <a:latin typeface="Calibri"/>
-              </a:rPr>
-              <a:t>STATUS</a:t>
-            </a:r>
-          </a:p>
-          <a:p>
-            <a:r>
-              <a:rPr sz="1400" b="0" i="1">
                 <a:solidFill>
                   <a:srgbClr val="6B7785"/>
                 </a:solidFill>
@@ -1793,7 +1217,7 @@
         <p:spPr>
           <a:xfrm>
             <a:off x="457200" y="1097280"/>
-            <a:ext cx="5532120" cy="1143000"/>
+            <a:ext cx="5532120" cy="5349240"/>
           </a:xfrm>
           <a:prstGeom prst="roundRect">
             <a:avLst>
@@ -1837,7 +1261,7 @@
         <p:spPr>
           <a:xfrm>
             <a:off x="6199632" y="1097280"/>
-            <a:ext cx="5532120" cy="1143000"/>
+            <a:ext cx="5532120" cy="5349240"/>
           </a:xfrm>
           <a:prstGeom prst="roundRect">
             <a:avLst>
@@ -1880,8 +1304,8 @@
         </p:nvSpPr>
         <p:spPr>
           <a:xfrm>
-            <a:off x="457200" y="2468880"/>
-            <a:ext cx="7040880" cy="3977639"/>
+            <a:off x="7871155" y="384048"/>
+            <a:ext cx="3863340" cy="329184"/>
           </a:xfrm>
           <a:prstGeom prst="roundRect">
             <a:avLst>
@@ -1889,7 +1313,7 @@
             </a:avLst>
           </a:prstGeom>
           <a:solidFill>
-            <a:srgbClr val="EEF4FB"/>
+            <a:srgbClr val="E3ECF7"/>
           </a:solidFill>
           <a:ln>
             <a:noFill/>
@@ -1918,102 +1342,14 @@
       </p:sp>
       <p:sp>
         <p:nvSpPr>
-          <p:cNvPr id="6" name="panel"/>
-          <p:cNvSpPr/>
-          <p:nvPr/>
-        </p:nvSpPr>
-        <p:spPr>
-          <a:xfrm>
-            <a:off x="7708392" y="2468880"/>
-            <a:ext cx="4023360" cy="3977639"/>
-          </a:xfrm>
-          <a:prstGeom prst="roundRect">
-            <a:avLst>
-              <a:gd name="adj" fmla="val 4500"/>
-            </a:avLst>
-          </a:prstGeom>
-          <a:solidFill>
-            <a:srgbClr val="EEF4FB"/>
-          </a:solidFill>
-          <a:ln>
-            <a:noFill/>
-          </a:ln>
-          <a:effectLst/>
-        </p:spPr>
-        <p:style>
-          <a:lnRef idx="1">
-            <a:schemeClr val="accent1"/>
-          </a:lnRef>
-          <a:fillRef idx="3">
-            <a:schemeClr val="accent1"/>
-          </a:fillRef>
-          <a:effectRef idx="2">
-            <a:schemeClr val="accent1"/>
-          </a:effectRef>
-          <a:fontRef idx="minor">
-            <a:schemeClr val="lt1"/>
-          </a:fontRef>
-        </p:style>
-        <p:txBody>
-          <a:bodyPr rtlCol="0" anchor="ctr"/>
-          <a:lstStyle/>
-          <a:p/>
-        </p:txBody>
-      </p:sp>
-      <p:sp>
-        <p:nvSpPr>
-          <p:cNvPr id="7" name="panel"/>
-          <p:cNvSpPr/>
-          <p:nvPr/>
-        </p:nvSpPr>
-        <p:spPr>
-          <a:xfrm>
-            <a:off x="7249363" y="384048"/>
-            <a:ext cx="4485132" cy="329184"/>
-          </a:xfrm>
-          <a:prstGeom prst="roundRect">
-            <a:avLst>
-              <a:gd name="adj" fmla="val 4500"/>
-            </a:avLst>
-          </a:prstGeom>
-          <a:solidFill>
-            <a:srgbClr val="E3ECF7"/>
-          </a:solidFill>
-          <a:ln>
-            <a:noFill/>
-          </a:ln>
-          <a:effectLst/>
-        </p:spPr>
-        <p:style>
-          <a:lnRef idx="1">
-            <a:schemeClr val="accent1"/>
-          </a:lnRef>
-          <a:fillRef idx="3">
-            <a:schemeClr val="accent1"/>
-          </a:fillRef>
-          <a:effectRef idx="2">
-            <a:schemeClr val="accent1"/>
-          </a:effectRef>
-          <a:fontRef idx="minor">
-            <a:schemeClr val="lt1"/>
-          </a:fontRef>
-        </p:style>
-        <p:txBody>
-          <a:bodyPr rtlCol="0" anchor="ctr"/>
-          <a:lstStyle/>
-          <a:p/>
-        </p:txBody>
-      </p:sp>
-      <p:sp>
-        <p:nvSpPr>
-          <p:cNvPr id="8" name="chip"/>
+          <p:cNvPr id="6" name="chip"/>
           <p:cNvSpPr txBox="1"/>
           <p:nvPr/>
         </p:nvSpPr>
         <p:spPr>
           <a:xfrm>
-            <a:off x="7249363" y="384048"/>
-            <a:ext cx="4485132" cy="329184"/>
+            <a:off x="7871155" y="384048"/>
+            <a:ext cx="3863340" cy="329184"/>
           </a:xfrm>
           <a:prstGeom prst="rect">
             <a:avLst/>
@@ -2033,20 +1369,20 @@
                 </a:solidFill>
                 <a:latin typeface="Calibri"/>
               </a:rPr>
-              <a:t>Wizard step 1 · The brief  →  Editor · Basics + Steps</a:t>
-            </a:r>
-          </a:p>
-        </p:txBody>
-      </p:sp>
-      <p:sp>
-        <p:nvSpPr>
-          <p:cNvPr id="9" name="help"/>
+              <a:t>Wizard step 1 · The brief  →  Editor · Basics</a:t>
+            </a:r>
+          </a:p>
+        </p:txBody>
+      </p:sp>
+      <p:sp>
+        <p:nvSpPr>
+          <p:cNvPr id="7" name="help"/>
           <p:cNvSpPr txBox="1"/>
           <p:nvPr/>
         </p:nvSpPr>
         <p:spPr>
           <a:xfrm>
-            <a:off x="457200" y="1965960"/>
+            <a:off x="457200" y="6172200"/>
             <a:ext cx="5532120" cy="274320"/>
           </a:xfrm>
           <a:prstGeom prst="rect">
@@ -2074,13 +1410,13 @@
       </p:sp>
       <p:sp>
         <p:nvSpPr>
-          <p:cNvPr id="10" name="help"/>
+          <p:cNvPr id="8" name="help"/>
           <p:cNvSpPr txBox="1"/>
           <p:nvPr/>
         </p:nvSpPr>
         <p:spPr>
           <a:xfrm>
-            <a:off x="6199632" y="1965960"/>
+            <a:off x="6199632" y="6172200"/>
             <a:ext cx="5532120" cy="274320"/>
           </a:xfrm>
           <a:prstGeom prst="rect">
@@ -2108,75 +1444,7 @@
       </p:sp>
       <p:sp>
         <p:nvSpPr>
-          <p:cNvPr id="11" name="help"/>
-          <p:cNvSpPr txBox="1"/>
-          <p:nvPr/>
-        </p:nvSpPr>
-        <p:spPr>
-          <a:xfrm>
-            <a:off x="457200" y="6172200"/>
-            <a:ext cx="7040880" cy="274320"/>
-          </a:xfrm>
-          <a:prstGeom prst="rect">
-            <a:avLst/>
-          </a:prstGeom>
-          <a:noFill/>
-        </p:spPr>
-        <p:txBody>
-          <a:bodyPr wrap="square" lIns="109728" rIns="109728" tIns="27432" bIns="27432" anchor="ctr">
-            <a:spAutoFit/>
-          </a:bodyPr>
-          <a:lstStyle/>
-          <a:p>
-            <a:r>
-              <a:rPr sz="750" b="0" i="1">
-                <a:solidFill>
-                  <a:srgbClr val="6B7785"/>
-                </a:solidFill>
-                <a:latin typeface="Calibri"/>
-              </a:rPr>
-              <a:t>coach: / roleplay: / observe: then what happens, e.g. “coach: does this qualify as harassment?”  → wizard: The steps</a:t>
-            </a:r>
-          </a:p>
-        </p:txBody>
-      </p:sp>
-      <p:sp>
-        <p:nvSpPr>
-          <p:cNvPr id="12" name="help"/>
-          <p:cNvSpPr txBox="1"/>
-          <p:nvPr/>
-        </p:nvSpPr>
-        <p:spPr>
-          <a:xfrm>
-            <a:off x="7708392" y="6172200"/>
-            <a:ext cx="4023360" cy="274320"/>
-          </a:xfrm>
-          <a:prstGeom prst="rect">
-            <a:avLst/>
-          </a:prstGeom>
-          <a:noFill/>
-        </p:spPr>
-        <p:txBody>
-          <a:bodyPr wrap="square" lIns="109728" rIns="109728" tIns="27432" bIns="27432" anchor="ctr">
-            <a:spAutoFit/>
-          </a:bodyPr>
-          <a:lstStyle/>
-          <a:p>
-            <a:r>
-              <a:rPr sz="750" b="0" i="1">
-                <a:solidFill>
-                  <a:srgbClr val="6B7785"/>
-                </a:solidFill>
-                <a:latin typeface="Calibri"/>
-              </a:rPr>
-              <a:t>Course file, slide numbers, policies. Paste the text on a SOURCE MATERIAL slide.</a:t>
-            </a:r>
-          </a:p>
-        </p:txBody>
-      </p:sp>
-      <p:sp>
-        <p:nvSpPr>
-          <p:cNvPr id="13" name="footer"/>
+          <p:cNvPr id="9" name="footer"/>
           <p:cNvSpPr txBox="1"/>
           <p:nvPr/>
         </p:nvSpPr>
@@ -2219,7 +1487,7 @@
       </p:sp>
       <p:sp>
         <p:nvSpPr>
-          <p:cNvPr id="14" name="footer"/>
+          <p:cNvPr id="10" name="footer"/>
           <p:cNvSpPr txBox="1"/>
           <p:nvPr/>
         </p:nvSpPr>
@@ -2253,7 +1521,7 @@
       </p:sp>
       <p:sp>
         <p:nvSpPr>
-          <p:cNvPr id="15" name="title"/>
+          <p:cNvPr id="11" name="title"/>
           <p:cNvSpPr/>
           <p:nvPr>
             <p:ph type="title"/>
@@ -2262,7 +1530,7 @@
         <p:spPr>
           <a:xfrm>
             <a:off x="457200" y="274320"/>
-            <a:ext cx="6609283" cy="640080"/>
+            <a:ext cx="7231075" cy="640080"/>
           </a:xfrm>
           <a:prstGeom prst="rect">
             <a:avLst/>
@@ -2302,7 +1570,7 @@
       </p:sp>
       <p:sp>
         <p:nvSpPr>
-          <p:cNvPr id="16" name="brief.topic"/>
+          <p:cNvPr id="12" name="brief.topic"/>
           <p:cNvSpPr/>
           <p:nvPr>
             <p:ph type="body" idx="10"/>
@@ -2311,7 +1579,7 @@
         <p:spPr>
           <a:xfrm>
             <a:off x="457200" y="1097280"/>
-            <a:ext cx="5532120" cy="868680"/>
+            <a:ext cx="5532120" cy="5074920"/>
           </a:xfrm>
           <a:prstGeom prst="rect">
             <a:avLst/>
@@ -2368,7 +1636,7 @@
       </p:sp>
       <p:sp>
         <p:nvSpPr>
-          <p:cNvPr id="17" name="brief.learner"/>
+          <p:cNvPr id="13" name="brief.learner"/>
           <p:cNvSpPr/>
           <p:nvPr>
             <p:ph type="body" idx="11"/>
@@ -2377,7 +1645,7 @@
         <p:spPr>
           <a:xfrm>
             <a:off x="6199632" y="1097280"/>
-            <a:ext cx="5532120" cy="868680"/>
+            <a:ext cx="5532120" cy="5074920"/>
           </a:xfrm>
           <a:prstGeom prst="rect">
             <a:avLst/>
@@ -2417,138 +1685,6 @@
                 <a:latin typeface="Calibri"/>
               </a:rPr>
               <a:t>THE LEARNER PLAYS</a:t>
-            </a:r>
-          </a:p>
-          <a:p>
-            <a:r>
-              <a:rPr sz="1200" b="0" i="1">
-                <a:solidFill>
-                  <a:srgbClr val="6B7785"/>
-                </a:solidFill>
-                <a:latin typeface="Calibri"/>
-              </a:rPr>
-              <a:t>Type here — keep the label line above.</a:t>
-            </a:r>
-          </a:p>
-        </p:txBody>
-      </p:sp>
-      <p:sp>
-        <p:nvSpPr>
-          <p:cNvPr id="18" name="brief.steps"/>
-          <p:cNvSpPr/>
-          <p:nvPr>
-            <p:ph type="body" idx="12"/>
-          </p:nvPr>
-        </p:nvSpPr>
-        <p:spPr>
-          <a:xfrm>
-            <a:off x="457200" y="2468880"/>
-            <a:ext cx="7040880" cy="3703320"/>
-          </a:xfrm>
-          <a:prstGeom prst="rect">
-            <a:avLst/>
-          </a:prstGeom>
-          <a:noFill/>
-        </p:spPr>
-        <p:txBody>
-          <a:bodyPr wrap="square" lIns="109728" rIns="109728" tIns="64008" anchor="t">
-            <a:normAutofit/>
-          </a:bodyPr>
-          <a:lstStyle>
-            <a:lvl1pPr marL="0" indent="0">
-              <a:spcBef>
-                <a:spcPts val="200"/>
-              </a:spcBef>
-              <a:buNone/>
-              <a:defRPr sz="1200" b="0">
-                <a:solidFill>
-                  <a:srgbClr val="1F2A37"/>
-                </a:solidFill>
-                <a:latin typeface="Calibri"/>
-              </a:defRPr>
-            </a:lvl1pPr>
-            <a:lvl2pPr marL="228600" indent="-228600">
-              <a:buChar char="•"/>
-              <a:defRPr sz="1200">
-                <a:latin typeface="Calibri"/>
-              </a:defRPr>
-            </a:lvl2pPr>
-          </a:lstStyle>
-          <a:p>
-            <a:r>
-              <a:rPr sz="900" b="1" i="0" spc="60">
-                <a:solidFill>
-                  <a:srgbClr val="0271CE"/>
-                </a:solidFill>
-                <a:latin typeface="Calibri"/>
-              </a:rPr>
-              <a:t>STEPS, IN ORDER — ONE PER LINE, EACH STARTING WITH ITS MODE</a:t>
-            </a:r>
-          </a:p>
-          <a:p>
-            <a:r>
-              <a:rPr sz="1200" b="0" i="1">
-                <a:solidFill>
-                  <a:srgbClr val="6B7785"/>
-                </a:solidFill>
-                <a:latin typeface="Calibri"/>
-              </a:rPr>
-              <a:t>Type here — keep the label line above.</a:t>
-            </a:r>
-          </a:p>
-        </p:txBody>
-      </p:sp>
-      <p:sp>
-        <p:nvSpPr>
-          <p:cNvPr id="19" name="brief.sources"/>
-          <p:cNvSpPr/>
-          <p:nvPr>
-            <p:ph type="body" idx="13"/>
-          </p:nvPr>
-        </p:nvSpPr>
-        <p:spPr>
-          <a:xfrm>
-            <a:off x="7708392" y="2468880"/>
-            <a:ext cx="4023360" cy="3703320"/>
-          </a:xfrm>
-          <a:prstGeom prst="rect">
-            <a:avLst/>
-          </a:prstGeom>
-          <a:noFill/>
-        </p:spPr>
-        <p:txBody>
-          <a:bodyPr wrap="square" lIns="109728" rIns="109728" tIns="64008" anchor="t">
-            <a:normAutofit/>
-          </a:bodyPr>
-          <a:lstStyle>
-            <a:lvl1pPr marL="0" indent="0">
-              <a:spcBef>
-                <a:spcPts val="200"/>
-              </a:spcBef>
-              <a:buNone/>
-              <a:defRPr sz="1200" b="0">
-                <a:solidFill>
-                  <a:srgbClr val="1F2A37"/>
-                </a:solidFill>
-                <a:latin typeface="Calibri"/>
-              </a:defRPr>
-            </a:lvl1pPr>
-            <a:lvl2pPr marL="228600" indent="-228600">
-              <a:buChar char="•"/>
-              <a:defRPr sz="1200">
-                <a:latin typeface="Calibri"/>
-              </a:defRPr>
-            </a:lvl2pPr>
-          </a:lstStyle>
-          <a:p>
-            <a:r>
-              <a:rPr sz="900" b="1" i="0" spc="60">
-                <a:solidFill>
-                  <a:srgbClr val="0271CE"/>
-                </a:solidFill>
-                <a:latin typeface="Calibri"/>
-              </a:rPr>
-              <a:t>SOURCE SLIDES OR DOCUMENTS</a:t>
             </a:r>
           </a:p>
           <a:p>
@@ -3278,7 +2414,7 @@
         <p:spPr>
           <a:xfrm>
             <a:off x="457200" y="1097280"/>
-            <a:ext cx="5532120" cy="2743200"/>
+            <a:ext cx="5532120" cy="3566160"/>
           </a:xfrm>
           <a:prstGeom prst="roundRect">
             <a:avLst>
@@ -3321,8 +2457,8 @@
         </p:nvSpPr>
         <p:spPr>
           <a:xfrm>
-            <a:off x="457200" y="4069080"/>
-            <a:ext cx="5532120" cy="2377440"/>
+            <a:off x="457200" y="4892040"/>
+            <a:ext cx="5532120" cy="1554480"/>
           </a:xfrm>
           <a:prstGeom prst="roundRect">
             <a:avLst>
@@ -3531,7 +2667,7 @@
         </p:nvSpPr>
         <p:spPr>
           <a:xfrm>
-            <a:off x="457200" y="3566160"/>
+            <a:off x="457200" y="4389120"/>
             <a:ext cx="5532120" cy="274320"/>
           </a:xfrm>
           <a:prstGeom prst="rect">
@@ -3780,7 +2916,7 @@
                 </a:solidFill>
                 <a:latin typeface="Calibri"/>
               </a:rPr>
-              <a:t>THE TEACHING</a:t>
+              <a:t>CORE TOPICS</a:t>
             </a:r>
           </a:p>
         </p:txBody>
@@ -3796,7 +2932,7 @@
         <p:spPr>
           <a:xfrm>
             <a:off x="457200" y="1097280"/>
-            <a:ext cx="5532120" cy="2468880"/>
+            <a:ext cx="5532120" cy="3291840"/>
           </a:xfrm>
           <a:prstGeom prst="rect">
             <a:avLst/>
@@ -3835,7 +2971,7 @@
                 </a:solidFill>
                 <a:latin typeface="Calibri"/>
               </a:rPr>
-              <a:t>MUST-KNOWS — 3 TO 6, ONE PER LINE</a:t>
+              <a:t>MUST-KNOWS — ONE PER LINE</a:t>
             </a:r>
           </a:p>
           <a:p>
@@ -3861,8 +2997,8 @@
         </p:nvSpPr>
         <p:spPr>
           <a:xfrm>
-            <a:off x="457200" y="4069080"/>
-            <a:ext cx="5532120" cy="2103120"/>
+            <a:off x="457200" y="4892040"/>
+            <a:ext cx="5532120" cy="1280160"/>
           </a:xfrm>
           <a:prstGeom prst="rect">
             <a:avLst/>
@@ -4521,7 +3657,7 @@
                 </a:solidFill>
                 <a:latin typeface="Calibri"/>
               </a:rPr>
-              <a:t>THE OPENING</a:t>
+              <a:t>INITIAL REFLECTION</a:t>
             </a:r>
           </a:p>
         </p:txBody>
@@ -4708,7 +3844,7 @@
                 </a:solidFill>
                 <a:latin typeface="Calibri"/>
               </a:rPr>
-              <a:t>LISTEN FOR — AND HOW TO ACKNOWLEDGE IT</a:t>
+              <a:t>LISTEN FOR</a:t>
             </a:r>
           </a:p>
           <a:p>
@@ -4763,7 +3899,7 @@
         <p:spPr>
           <a:xfrm>
             <a:off x="457200" y="1097280"/>
-            <a:ext cx="2103120" cy="658368"/>
+            <a:ext cx="2103120" cy="704088"/>
           </a:xfrm>
           <a:prstGeom prst="roundRect">
             <a:avLst>
@@ -4807,7 +3943,7 @@
         <p:spPr>
           <a:xfrm>
             <a:off x="2706624" y="1097280"/>
-            <a:ext cx="2103120" cy="658368"/>
+            <a:ext cx="2103120" cy="704088"/>
           </a:xfrm>
           <a:prstGeom prst="roundRect">
             <a:avLst>
@@ -4851,7 +3987,7 @@
         <p:spPr>
           <a:xfrm>
             <a:off x="4956048" y="1097280"/>
-            <a:ext cx="1005840" cy="658368"/>
+            <a:ext cx="1005840" cy="704088"/>
           </a:xfrm>
           <a:prstGeom prst="roundRect">
             <a:avLst>
@@ -5236,7 +4372,7 @@
         </p:nvSpPr>
         <p:spPr>
           <a:xfrm>
-            <a:off x="457200" y="1481328"/>
+            <a:off x="457200" y="1527048"/>
             <a:ext cx="2103120" cy="274320"/>
           </a:xfrm>
           <a:prstGeom prst="rect">
@@ -5270,7 +4406,7 @@
         </p:nvSpPr>
         <p:spPr>
           <a:xfrm>
-            <a:off x="2706624" y="1481328"/>
+            <a:off x="2706624" y="1527048"/>
             <a:ext cx="2103120" cy="274320"/>
           </a:xfrm>
           <a:prstGeom prst="rect">
@@ -5304,7 +4440,7 @@
         </p:nvSpPr>
         <p:spPr>
           <a:xfrm>
-            <a:off x="4956048" y="1481328"/>
+            <a:off x="4956048" y="1527048"/>
             <a:ext cx="1005840" cy="274320"/>
           </a:xfrm>
           <a:prstGeom prst="rect">
@@ -5680,7 +4816,73 @@
         <p:spPr>
           <a:xfrm>
             <a:off x="457200" y="1097280"/>
-            <a:ext cx="2103120" cy="384048"/>
+            <a:ext cx="2103120" cy="429768"/>
+          </a:xfrm>
+          <a:prstGeom prst="rect">
+            <a:avLst/>
+          </a:prstGeom>
+          <a:noFill/>
+        </p:spPr>
+        <p:txBody>
+          <a:bodyPr wrap="square" lIns="109728" rIns="109728" tIns="64008" anchor="t">
+            <a:normAutofit/>
+          </a:bodyPr>
+          <a:lstStyle>
+            <a:lvl1pPr marL="0" indent="0">
+              <a:spcBef>
+                <a:spcPts val="200"/>
+              </a:spcBef>
+              <a:buNone/>
+              <a:defRPr sz="1600" b="0">
+                <a:solidFill>
+                  <a:srgbClr val="1F2A37"/>
+                </a:solidFill>
+                <a:latin typeface="Calibri"/>
+              </a:defRPr>
+            </a:lvl1pPr>
+            <a:lvl2pPr marL="228600" indent="-228600">
+              <a:buChar char="•"/>
+              <a:defRPr sz="1600">
+                <a:latin typeface="Calibri"/>
+              </a:defRPr>
+            </a:lvl2pPr>
+          </a:lstStyle>
+          <a:p>
+            <a:r>
+              <a:rPr sz="900" b="1" i="0" spc="60">
+                <a:solidFill>
+                  <a:srgbClr val="0271CE"/>
+                </a:solidFill>
+                <a:latin typeface="Calibri"/>
+              </a:rPr>
+              <a:t>MODE</a:t>
+            </a:r>
+          </a:p>
+          <a:p>
+            <a:r>
+              <a:rPr sz="1600" b="0" i="1">
+                <a:solidFill>
+                  <a:srgbClr val="6B7785"/>
+                </a:solidFill>
+                <a:latin typeface="Calibri"/>
+              </a:rPr>
+              <a:t>Type here — keep the label line above.</a:t>
+            </a:r>
+          </a:p>
+        </p:txBody>
+      </p:sp>
+      <p:sp>
+        <p:nvSpPr>
+          <p:cNvPr id="27" name="step.right"/>
+          <p:cNvSpPr/>
+          <p:nvPr>
+            <p:ph type="body" idx="11"/>
+          </p:nvPr>
+        </p:nvSpPr>
+        <p:spPr>
+          <a:xfrm>
+            <a:off x="2706624" y="1097280"/>
+            <a:ext cx="2103120" cy="429768"/>
           </a:xfrm>
           <a:prstGeom prst="rect">
             <a:avLst/>
@@ -5719,7 +4921,7 @@
                 </a:solidFill>
                 <a:latin typeface="Calibri"/>
               </a:rPr>
-              <a:t>MODE</a:t>
+              <a:t>IS THERE A RIGHT ANSWER?</a:t>
             </a:r>
           </a:p>
           <a:p>
@@ -5737,16 +4939,16 @@
       </p:sp>
       <p:sp>
         <p:nvSpPr>
-          <p:cNvPr id="27" name="step.right"/>
+          <p:cNvPr id="28" name="step.turns"/>
           <p:cNvSpPr/>
           <p:nvPr>
-            <p:ph type="body" idx="11"/>
+            <p:ph type="body" idx="12"/>
           </p:nvPr>
         </p:nvSpPr>
         <p:spPr>
           <a:xfrm>
-            <a:off x="2706624" y="1097280"/>
-            <a:ext cx="2103120" cy="384048"/>
+            <a:off x="4956048" y="1097280"/>
+            <a:ext cx="1005840" cy="429768"/>
           </a:xfrm>
           <a:prstGeom prst="rect">
             <a:avLst/>
@@ -5785,72 +4987,6 @@
                 </a:solidFill>
                 <a:latin typeface="Calibri"/>
               </a:rPr>
-              <a:t>RIGHT ANSWER?</a:t>
-            </a:r>
-          </a:p>
-          <a:p>
-            <a:r>
-              <a:rPr sz="1100" b="0" i="1">
-                <a:solidFill>
-                  <a:srgbClr val="6B7785"/>
-                </a:solidFill>
-                <a:latin typeface="Calibri"/>
-              </a:rPr>
-              <a:t>Type here — keep the label line above.</a:t>
-            </a:r>
-          </a:p>
-        </p:txBody>
-      </p:sp>
-      <p:sp>
-        <p:nvSpPr>
-          <p:cNvPr id="28" name="step.turns"/>
-          <p:cNvSpPr/>
-          <p:nvPr>
-            <p:ph type="body" idx="12"/>
-          </p:nvPr>
-        </p:nvSpPr>
-        <p:spPr>
-          <a:xfrm>
-            <a:off x="4956048" y="1097280"/>
-            <a:ext cx="1005840" cy="384048"/>
-          </a:xfrm>
-          <a:prstGeom prst="rect">
-            <a:avLst/>
-          </a:prstGeom>
-          <a:noFill/>
-        </p:spPr>
-        <p:txBody>
-          <a:bodyPr wrap="square" lIns="109728" rIns="109728" tIns="64008" anchor="t">
-            <a:normAutofit/>
-          </a:bodyPr>
-          <a:lstStyle>
-            <a:lvl1pPr marL="0" indent="0">
-              <a:spcBef>
-                <a:spcPts val="200"/>
-              </a:spcBef>
-              <a:buNone/>
-              <a:defRPr sz="1100" b="0">
-                <a:solidFill>
-                  <a:srgbClr val="1F2A37"/>
-                </a:solidFill>
-                <a:latin typeface="Calibri"/>
-              </a:defRPr>
-            </a:lvl1pPr>
-            <a:lvl2pPr marL="228600" indent="-228600">
-              <a:buChar char="•"/>
-              <a:defRPr sz="1100">
-                <a:latin typeface="Calibri"/>
-              </a:defRPr>
-            </a:lvl2pPr>
-          </a:lstStyle>
-          <a:p>
-            <a:r>
-              <a:rPr sz="900" b="1" i="0" spc="60">
-                <a:solidFill>
-                  <a:srgbClr val="0271CE"/>
-                </a:solidFill>
-                <a:latin typeface="Calibri"/>
-              </a:rPr>
               <a:t>TURNS</a:t>
             </a:r>
           </a:p>
@@ -6049,7 +5185,7 @@
                 </a:solidFill>
                 <a:latin typeface="Calibri"/>
               </a:rPr>
-              <a:t>UNTHOUGHTFUL</a:t>
+              <a:t>RESPONSE: UNTHOUGHTFUL</a:t>
             </a:r>
           </a:p>
           <a:p>
@@ -6115,7 +5251,7 @@
                 </a:solidFill>
                 <a:latin typeface="Calibri"/>
               </a:rPr>
-              <a:t>NEUTRAL</a:t>
+              <a:t>RESPONSE: NEUTRAL</a:t>
             </a:r>
           </a:p>
           <a:p>
@@ -6181,7 +5317,7 @@
                 </a:solidFill>
                 <a:latin typeface="Calibri"/>
               </a:rPr>
-              <a:t>STRONG</a:t>
+              <a:t>RESPONSE: STRONG</a:t>
             </a:r>
           </a:p>
           <a:p>
@@ -6247,7 +5383,7 @@
                 </a:solidFill>
                 <a:latin typeface="Calibri"/>
               </a:rPr>
-              <a:t>DEBRIEF LANDS — 2 TO 4 POINTS EVERY LEARNER HEARS, HOWEVER THE ATTEMPT WENT</a:t>
+              <a:t>DEBRIEF — 2 TO 4 POINTS EVERY LEARNER HEARS, HOWEVER THE ATTEMPT WENT</a:t>
             </a:r>
           </a:p>
           <a:p>
@@ -6781,7 +5917,7 @@
                 </a:solidFill>
                 <a:latin typeface="Calibri"/>
               </a:rPr>
-              <a:t>UNTHOUGHTFUL</a:t>
+              <a:t>EXAMPLE RESPONSE: UNTHOUGHTFUL</a:t>
             </a:r>
           </a:p>
           <a:p>
@@ -6847,7 +5983,7 @@
                 </a:solidFill>
                 <a:latin typeface="Calibri"/>
               </a:rPr>
-              <a:t>NEUTRAL</a:t>
+              <a:t>EXAMPLE RESPONSE: NEUTRAL</a:t>
             </a:r>
           </a:p>
           <a:p>
@@ -6913,7 +6049,7 @@
                 </a:solidFill>
                 <a:latin typeface="Calibri"/>
               </a:rPr>
-              <a:t>STRONG</a:t>
+              <a:t>EXAMPLE RESPONSE: STRONG</a:t>
             </a:r>
           </a:p>
           <a:p>
@@ -7012,7 +6148,7 @@
         <p:spPr>
           <a:xfrm>
             <a:off x="6199632" y="1097280"/>
-            <a:ext cx="5532120" cy="3063240"/>
+            <a:ext cx="5532120" cy="5349240"/>
           </a:xfrm>
           <a:prstGeom prst="roundRect">
             <a:avLst>
@@ -7055,8 +6191,8 @@
         </p:nvSpPr>
         <p:spPr>
           <a:xfrm>
-            <a:off x="6199632" y="4389120"/>
-            <a:ext cx="2651760" cy="2057400"/>
+            <a:off x="7249363" y="384048"/>
+            <a:ext cx="4485132" cy="329184"/>
           </a:xfrm>
           <a:prstGeom prst="roundRect">
             <a:avLst>
@@ -7064,7 +6200,7 @@
             </a:avLst>
           </a:prstGeom>
           <a:solidFill>
-            <a:srgbClr val="EEF4FB"/>
+            <a:srgbClr val="E3ECF7"/>
           </a:solidFill>
           <a:ln>
             <a:noFill/>
@@ -7093,95 +6229,7 @@
       </p:sp>
       <p:sp>
         <p:nvSpPr>
-          <p:cNvPr id="6" name="panel"/>
-          <p:cNvSpPr/>
-          <p:nvPr/>
-        </p:nvSpPr>
-        <p:spPr>
-          <a:xfrm>
-            <a:off x="9079992" y="4389120"/>
-            <a:ext cx="2651760" cy="2057400"/>
-          </a:xfrm>
-          <a:prstGeom prst="roundRect">
-            <a:avLst>
-              <a:gd name="adj" fmla="val 4500"/>
-            </a:avLst>
-          </a:prstGeom>
-          <a:solidFill>
-            <a:srgbClr val="EEF4FB"/>
-          </a:solidFill>
-          <a:ln>
-            <a:noFill/>
-          </a:ln>
-          <a:effectLst/>
-        </p:spPr>
-        <p:style>
-          <a:lnRef idx="1">
-            <a:schemeClr val="accent1"/>
-          </a:lnRef>
-          <a:fillRef idx="3">
-            <a:schemeClr val="accent1"/>
-          </a:fillRef>
-          <a:effectRef idx="2">
-            <a:schemeClr val="accent1"/>
-          </a:effectRef>
-          <a:fontRef idx="minor">
-            <a:schemeClr val="lt1"/>
-          </a:fontRef>
-        </p:style>
-        <p:txBody>
-          <a:bodyPr rtlCol="0" anchor="ctr"/>
-          <a:lstStyle/>
-          <a:p/>
-        </p:txBody>
-      </p:sp>
-      <p:sp>
-        <p:nvSpPr>
-          <p:cNvPr id="7" name="panel"/>
-          <p:cNvSpPr/>
-          <p:nvPr/>
-        </p:nvSpPr>
-        <p:spPr>
-          <a:xfrm>
-            <a:off x="7249363" y="384048"/>
-            <a:ext cx="4485132" cy="329184"/>
-          </a:xfrm>
-          <a:prstGeom prst="roundRect">
-            <a:avLst>
-              <a:gd name="adj" fmla="val 4500"/>
-            </a:avLst>
-          </a:prstGeom>
-          <a:solidFill>
-            <a:srgbClr val="E3ECF7"/>
-          </a:solidFill>
-          <a:ln>
-            <a:noFill/>
-          </a:ln>
-          <a:effectLst/>
-        </p:spPr>
-        <p:style>
-          <a:lnRef idx="1">
-            <a:schemeClr val="accent1"/>
-          </a:lnRef>
-          <a:fillRef idx="3">
-            <a:schemeClr val="accent1"/>
-          </a:fillRef>
-          <a:effectRef idx="2">
-            <a:schemeClr val="accent1"/>
-          </a:effectRef>
-          <a:fontRef idx="minor">
-            <a:schemeClr val="lt1"/>
-          </a:fontRef>
-        </p:style>
-        <p:txBody>
-          <a:bodyPr rtlCol="0" anchor="ctr"/>
-          <a:lstStyle/>
-          <a:p/>
-        </p:txBody>
-      </p:sp>
-      <p:sp>
-        <p:nvSpPr>
-          <p:cNvPr id="8" name="chip"/>
+          <p:cNvPr id="6" name="chip"/>
           <p:cNvSpPr txBox="1"/>
           <p:nvPr/>
         </p:nvSpPr>
@@ -7215,7 +6263,7 @@
       </p:sp>
       <p:sp>
         <p:nvSpPr>
-          <p:cNvPr id="9" name="help"/>
+          <p:cNvPr id="7" name="help"/>
           <p:cNvSpPr txBox="1"/>
           <p:nvPr/>
         </p:nvSpPr>
@@ -7249,13 +6297,13 @@
       </p:sp>
       <p:sp>
         <p:nvSpPr>
-          <p:cNvPr id="10" name="help"/>
+          <p:cNvPr id="8" name="help"/>
           <p:cNvSpPr txBox="1"/>
           <p:nvPr/>
         </p:nvSpPr>
         <p:spPr>
           <a:xfrm>
-            <a:off x="6199632" y="3886200"/>
+            <a:off x="6199632" y="6172200"/>
             <a:ext cx="5532120" cy="274320"/>
           </a:xfrm>
           <a:prstGeom prst="rect">
@@ -7292,75 +6340,7 @@
       </p:sp>
       <p:sp>
         <p:nvSpPr>
-          <p:cNvPr id="11" name="help"/>
-          <p:cNvSpPr txBox="1"/>
-          <p:nvPr/>
-        </p:nvSpPr>
-        <p:spPr>
-          <a:xfrm>
-            <a:off x="6199632" y="6172200"/>
-            <a:ext cx="2651760" cy="274320"/>
-          </a:xfrm>
-          <a:prstGeom prst="rect">
-            <a:avLst/>
-          </a:prstGeom>
-          <a:noFill/>
-        </p:spPr>
-        <p:txBody>
-          <a:bodyPr wrap="square" lIns="109728" rIns="109728" tIns="27432" bIns="27432" anchor="ctr">
-            <a:spAutoFit/>
-          </a:bodyPr>
-          <a:lstStyle/>
-          <a:p>
-            <a:r>
-              <a:rPr sz="750" b="0" i="1">
-                <a:solidFill>
-                  <a:srgbClr val="6B7785"/>
-                </a:solidFill>
-                <a:latin typeface="Calibri"/>
-              </a:rPr>
-              <a:t>Regulations, standards only. Ships to the learner.</a:t>
-            </a:r>
-          </a:p>
-        </p:txBody>
-      </p:sp>
-      <p:sp>
-        <p:nvSpPr>
-          <p:cNvPr id="12" name="help"/>
-          <p:cNvSpPr txBox="1"/>
-          <p:nvPr/>
-        </p:nvSpPr>
-        <p:spPr>
-          <a:xfrm>
-            <a:off x="9079992" y="6172200"/>
-            <a:ext cx="2651760" cy="274320"/>
-          </a:xfrm>
-          <a:prstGeom prst="rect">
-            <a:avLst/>
-          </a:prstGeom>
-          <a:noFill/>
-        </p:spPr>
-        <p:txBody>
-          <a:bodyPr wrap="square" lIns="109728" rIns="109728" tIns="27432" bIns="27432" anchor="ctr">
-            <a:spAutoFit/>
-          </a:bodyPr>
-          <a:lstStyle/>
-          <a:p>
-            <a:r>
-              <a:rPr sz="750" b="0" i="1">
-                <a:solidFill>
-                  <a:srgbClr val="6B7785"/>
-                </a:solidFill>
-                <a:latin typeface="Calibri"/>
-              </a:rPr>
-              <a:t>Course slide numbers. Never ships.</a:t>
-            </a:r>
-          </a:p>
-        </p:txBody>
-      </p:sp>
-      <p:sp>
-        <p:nvSpPr>
-          <p:cNvPr id="13" name="footer"/>
+          <p:cNvPr id="9" name="footer"/>
           <p:cNvSpPr txBox="1"/>
           <p:nvPr/>
         </p:nvSpPr>
@@ -7403,7 +6383,7 @@
       </p:sp>
       <p:sp>
         <p:nvSpPr>
-          <p:cNvPr id="14" name="footer"/>
+          <p:cNvPr id="10" name="footer"/>
           <p:cNvSpPr txBox="1"/>
           <p:nvPr/>
         </p:nvSpPr>
@@ -7437,7 +6417,7 @@
       </p:sp>
       <p:sp>
         <p:nvSpPr>
-          <p:cNvPr id="15" name="title"/>
+          <p:cNvPr id="11" name="title"/>
           <p:cNvSpPr/>
           <p:nvPr>
             <p:ph type="title"/>
@@ -7486,7 +6466,7 @@
       </p:sp>
       <p:sp>
         <p:nvSpPr>
-          <p:cNvPr id="16" name="close.components"/>
+          <p:cNvPr id="12" name="close.components"/>
           <p:cNvSpPr/>
           <p:nvPr>
             <p:ph type="body" idx="10"/>
@@ -7552,7 +6532,7 @@
       </p:sp>
       <p:sp>
         <p:nvSpPr>
-          <p:cNvPr id="17" name="close.summary"/>
+          <p:cNvPr id="13" name="close.summary"/>
           <p:cNvSpPr/>
           <p:nvPr>
             <p:ph type="body" idx="11"/>
@@ -7561,7 +6541,7 @@
         <p:spPr>
           <a:xfrm>
             <a:off x="6199632" y="1097280"/>
-            <a:ext cx="5532120" cy="2788920"/>
+            <a:ext cx="5532120" cy="5074920"/>
           </a:xfrm>
           <a:prstGeom prst="rect">
             <a:avLst/>
@@ -7606,138 +6586,6 @@
           <a:p>
             <a:r>
               <a:rPr sz="1100" b="0" i="1">
-                <a:solidFill>
-                  <a:srgbClr val="6B7785"/>
-                </a:solidFill>
-                <a:latin typeface="Calibri"/>
-              </a:rPr>
-              <a:t>Type here — keep the label line above.</a:t>
-            </a:r>
-          </a:p>
-        </p:txBody>
-      </p:sp>
-      <p:sp>
-        <p:nvSpPr>
-          <p:cNvPr id="18" name="close.authorities"/>
-          <p:cNvSpPr/>
-          <p:nvPr>
-            <p:ph type="body" idx="12"/>
-          </p:nvPr>
-        </p:nvSpPr>
-        <p:spPr>
-          <a:xfrm>
-            <a:off x="6199632" y="4389120"/>
-            <a:ext cx="2651760" cy="1783080"/>
-          </a:xfrm>
-          <a:prstGeom prst="rect">
-            <a:avLst/>
-          </a:prstGeom>
-          <a:noFill/>
-        </p:spPr>
-        <p:txBody>
-          <a:bodyPr wrap="square" lIns="109728" rIns="109728" tIns="64008" anchor="t">
-            <a:normAutofit/>
-          </a:bodyPr>
-          <a:lstStyle>
-            <a:lvl1pPr marL="0" indent="0">
-              <a:spcBef>
-                <a:spcPts val="200"/>
-              </a:spcBef>
-              <a:buNone/>
-              <a:defRPr sz="1000" b="0">
-                <a:solidFill>
-                  <a:srgbClr val="1F2A37"/>
-                </a:solidFill>
-                <a:latin typeface="Calibri"/>
-              </a:defRPr>
-            </a:lvl1pPr>
-            <a:lvl2pPr marL="228600" indent="-228600">
-              <a:buChar char="•"/>
-              <a:defRPr sz="1000">
-                <a:latin typeface="Calibri"/>
-              </a:defRPr>
-            </a:lvl2pPr>
-          </a:lstStyle>
-          <a:p>
-            <a:r>
-              <a:rPr sz="900" b="1" i="0" spc="60">
-                <a:solidFill>
-                  <a:srgbClr val="0271CE"/>
-                </a:solidFill>
-                <a:latin typeface="Calibri"/>
-              </a:rPr>
-              <a:t>EXTERNAL AUTHORITIES</a:t>
-            </a:r>
-          </a:p>
-          <a:p>
-            <a:r>
-              <a:rPr sz="1000" b="0" i="1">
-                <a:solidFill>
-                  <a:srgbClr val="6B7785"/>
-                </a:solidFill>
-                <a:latin typeface="Calibri"/>
-              </a:rPr>
-              <a:t>Type here — keep the label line above.</a:t>
-            </a:r>
-          </a:p>
-        </p:txBody>
-      </p:sp>
-      <p:sp>
-        <p:nvSpPr>
-          <p:cNvPr id="19" name="close.internal"/>
-          <p:cNvSpPr/>
-          <p:nvPr>
-            <p:ph type="body" idx="13"/>
-          </p:nvPr>
-        </p:nvSpPr>
-        <p:spPr>
-          <a:xfrm>
-            <a:off x="9079992" y="4389120"/>
-            <a:ext cx="2651760" cy="1783080"/>
-          </a:xfrm>
-          <a:prstGeom prst="rect">
-            <a:avLst/>
-          </a:prstGeom>
-          <a:noFill/>
-        </p:spPr>
-        <p:txBody>
-          <a:bodyPr wrap="square" lIns="109728" rIns="109728" tIns="64008" anchor="t">
-            <a:normAutofit/>
-          </a:bodyPr>
-          <a:lstStyle>
-            <a:lvl1pPr marL="0" indent="0">
-              <a:spcBef>
-                <a:spcPts val="200"/>
-              </a:spcBef>
-              <a:buNone/>
-              <a:defRPr sz="1000" b="0">
-                <a:solidFill>
-                  <a:srgbClr val="1F2A37"/>
-                </a:solidFill>
-                <a:latin typeface="Calibri"/>
-              </a:defRPr>
-            </a:lvl1pPr>
-            <a:lvl2pPr marL="228600" indent="-228600">
-              <a:buChar char="•"/>
-              <a:defRPr sz="1000">
-                <a:latin typeface="Calibri"/>
-              </a:defRPr>
-            </a:lvl2pPr>
-          </a:lstStyle>
-          <a:p>
-            <a:r>
-              <a:rPr sz="900" b="1" i="0" spc="60">
-                <a:solidFill>
-                  <a:srgbClr val="0271CE"/>
-                </a:solidFill>
-                <a:latin typeface="Calibri"/>
-              </a:rPr>
-              <a:t>INTERNAL SOURCE SLIDES</a:t>
-            </a:r>
-          </a:p>
-          <a:p>
-            <a:r>
-              <a:rPr sz="1000" b="0" i="1">
                 <a:solidFill>
                   <a:srgbClr val="6B7785"/>
                 </a:solidFill>
@@ -8679,7 +7527,7 @@
                 </a:solidFill>
                 <a:latin typeface="Calibri"/>
               </a:rPr>
-              <a:t>SCENARIO BRIEF</a:t>
+              <a:t>SCENARIO BASICS</a:t>
             </a:r>
           </a:p>
         </p:txBody>
@@ -8708,16 +7556,16 @@
               </a:rPr>
               <a:t>SCENARIO TITLE</a:t>
             </a:r>
-            <a:endParaRPr sz="1950" b="0" i="0">
-              <a:solidFill>
-                <a:srgbClr val="1F2A37"/>
-              </a:solidFill>
-              <a:latin typeface="Calibri"/>
-            </a:endParaRPr>
-          </a:p>
-          <a:p>
-            <a:r>
-              <a:rPr sz="1950" b="0" i="0">
+            <a:endParaRPr sz="2400" b="0" i="0">
+              <a:solidFill>
+                <a:srgbClr val="1F2A37"/>
+              </a:solidFill>
+              <a:latin typeface="Calibri"/>
+            </a:endParaRPr>
+          </a:p>
+          <a:p>
+            <a:r>
+              <a:rPr sz="2400" b="0" i="0">
                 <a:solidFill>
                   <a:srgbClr val="1F2A37"/>
                 </a:solidFill>
@@ -8725,16 +7573,16 @@
               </a:rPr>
               <a:t>The Marshall Scenario</a:t>
             </a:r>
-            <a:endParaRPr sz="1950" b="0" i="0">
-              <a:solidFill>
-                <a:srgbClr val="1F2A37"/>
-              </a:solidFill>
-              <a:latin typeface="Calibri"/>
-            </a:endParaRPr>
-          </a:p>
-          <a:p>
-            <a:r>
-              <a:rPr sz="1950" b="0" i="0">
+            <a:endParaRPr sz="2400" b="0" i="0">
+              <a:solidFill>
+                <a:srgbClr val="1F2A37"/>
+              </a:solidFill>
+              <a:latin typeface="Calibri"/>
+            </a:endParaRPr>
+          </a:p>
+          <a:p>
+            <a:r>
+              <a:rPr sz="2400" b="0" i="0">
                 <a:solidFill>
                   <a:srgbClr val="1F2A37"/>
                 </a:solidFill>
@@ -8742,207 +7590,7 @@
               </a:rPr>
               <a:t>Sex-Based Harassment, Empathy &amp; Bystander Intervention</a:t>
             </a:r>
-            <a:endParaRPr sz="1950" b="0" i="0">
-              <a:solidFill>
-                <a:srgbClr val="1F2A37"/>
-              </a:solidFill>
-              <a:latin typeface="Calibri"/>
-            </a:endParaRPr>
-          </a:p>
-        </p:txBody>
-      </p:sp>
-      <p:sp>
-        <p:nvSpPr>
-          <p:cNvPr id="4" name="cover.training"/>
-          <p:cNvSpPr>
-            <a:spLocks noGrp="1"/>
-          </p:cNvSpPr>
-          <p:nvPr>
-            <p:ph type="body" idx="11"/>
-          </p:nvPr>
-        </p:nvSpPr>
-        <p:spPr/>
-        <p:txBody>
-          <a:bodyPr/>
-          <a:lstStyle/>
-          <a:p>
-            <a:r>
-              <a:rPr sz="900" b="1" i="0" spc="60">
-                <a:solidFill>
-                  <a:srgbClr val="0271CE"/>
-                </a:solidFill>
-                <a:latin typeface="Calibri"/>
-              </a:rPr>
-              <a:t>TRAINING IT LIVES INSIDE</a:t>
-            </a:r>
-            <a:endParaRPr sz="1400" b="0" i="0">
-              <a:solidFill>
-                <a:srgbClr val="1F2A37"/>
-              </a:solidFill>
-              <a:latin typeface="Calibri"/>
-            </a:endParaRPr>
-          </a:p>
-          <a:p>
-            <a:r>
-              <a:rPr sz="1400" b="0" i="0">
-                <a:solidFill>
-                  <a:srgbClr val="1F2A37"/>
-                </a:solidFill>
-                <a:latin typeface="Calibri"/>
-              </a:rPr>
-              <a:t>Harassment Prevention for Employees (JCOM-40198)</a:t>
-            </a:r>
-            <a:endParaRPr sz="1400" b="0" i="0">
-              <a:solidFill>
-                <a:srgbClr val="1F2A37"/>
-              </a:solidFill>
-              <a:latin typeface="Calibri"/>
-            </a:endParaRPr>
-          </a:p>
-        </p:txBody>
-      </p:sp>
-      <p:sp>
-        <p:nvSpPr>
-          <p:cNvPr id="5" name="cover.owner"/>
-          <p:cNvSpPr>
-            <a:spLocks noGrp="1"/>
-          </p:cNvSpPr>
-          <p:nvPr>
-            <p:ph type="body" idx="12"/>
-          </p:nvPr>
-        </p:nvSpPr>
-        <p:spPr/>
-        <p:txBody>
-          <a:bodyPr/>
-          <a:lstStyle/>
-          <a:p>
-            <a:r>
-              <a:rPr sz="900" b="1" i="0" spc="60">
-                <a:solidFill>
-                  <a:srgbClr val="0271CE"/>
-                </a:solidFill>
-                <a:latin typeface="Calibri"/>
-              </a:rPr>
-              <a:t>OWNER</a:t>
-            </a:r>
-            <a:endParaRPr sz="1400" b="0" i="0">
-              <a:solidFill>
-                <a:srgbClr val="1F2A37"/>
-              </a:solidFill>
-              <a:latin typeface="Calibri"/>
-            </a:endParaRPr>
-          </a:p>
-          <a:p>
-            <a:r>
-              <a:rPr sz="1400" b="0" i="0">
-                <a:solidFill>
-                  <a:srgbClr val="1F2A37"/>
-                </a:solidFill>
-                <a:latin typeface="Calibri"/>
-              </a:rPr>
-              <a:t>K&amp;A team · Scenario Simulator POC</a:t>
-            </a:r>
-            <a:endParaRPr sz="1400" b="0" i="0">
-              <a:solidFill>
-                <a:srgbClr val="1F2A37"/>
-              </a:solidFill>
-              <a:latin typeface="Calibri"/>
-            </a:endParaRPr>
-          </a:p>
-        </p:txBody>
-      </p:sp>
-      <p:sp>
-        <p:nvSpPr>
-          <p:cNvPr id="6" name="cover.version"/>
-          <p:cNvSpPr>
-            <a:spLocks noGrp="1"/>
-          </p:cNvSpPr>
-          <p:nvPr>
-            <p:ph type="body" idx="13"/>
-          </p:nvPr>
-        </p:nvSpPr>
-        <p:spPr/>
-        <p:txBody>
-          <a:bodyPr/>
-          <a:lstStyle/>
-          <a:p>
-            <a:r>
-              <a:rPr sz="900" b="1" i="0" spc="60">
-                <a:solidFill>
-                  <a:srgbClr val="0271CE"/>
-                </a:solidFill>
-                <a:latin typeface="Calibri"/>
-              </a:rPr>
-              <a:t>VERSION · DATE</a:t>
-            </a:r>
-            <a:endParaRPr sz="1050" b="0" i="0">
-              <a:solidFill>
-                <a:srgbClr val="1F2A37"/>
-              </a:solidFill>
-              <a:latin typeface="Calibri"/>
-            </a:endParaRPr>
-          </a:p>
-          <a:p>
-            <a:r>
-              <a:rPr sz="1050" b="0" i="0">
-                <a:solidFill>
-                  <a:srgbClr val="1F2A37"/>
-                </a:solidFill>
-                <a:latin typeface="Calibri"/>
-              </a:rPr>
-              <a:t>Brief v1 · re-homed from POC deck v3 (May 2026) · 2026-09-11</a:t>
-            </a:r>
-            <a:endParaRPr sz="1050" b="0" i="0">
-              <a:solidFill>
-                <a:srgbClr val="1F2A37"/>
-              </a:solidFill>
-              <a:latin typeface="Calibri"/>
-            </a:endParaRPr>
-          </a:p>
-        </p:txBody>
-      </p:sp>
-      <p:sp>
-        <p:nvSpPr>
-          <p:cNvPr id="7" name="cover.status"/>
-          <p:cNvSpPr>
-            <a:spLocks noGrp="1"/>
-          </p:cNvSpPr>
-          <p:nvPr>
-            <p:ph type="body" idx="14"/>
-          </p:nvPr>
-        </p:nvSpPr>
-        <p:spPr/>
-        <p:txBody>
-          <a:bodyPr/>
-          <a:lstStyle/>
-          <a:p>
-            <a:r>
-              <a:rPr sz="900" b="1" i="0" spc="60">
-                <a:solidFill>
-                  <a:srgbClr val="0271CE"/>
-                </a:solidFill>
-                <a:latin typeface="Calibri"/>
-              </a:rPr>
-              <a:t>STATUS</a:t>
-            </a:r>
-            <a:endParaRPr sz="1350" b="0" i="0">
-              <a:solidFill>
-                <a:srgbClr val="1F2A37"/>
-              </a:solidFill>
-              <a:latin typeface="Calibri"/>
-            </a:endParaRPr>
-          </a:p>
-          <a:p>
-            <a:r>
-              <a:rPr sz="1350" b="0" i="0">
-                <a:solidFill>
-                  <a:srgbClr val="1F2A37"/>
-                </a:solidFill>
-                <a:latin typeface="Calibri"/>
-              </a:rPr>
-              <a:t>Worked example — the 32-slide POC deck, restated on the Scenario Brief template</a:t>
-            </a:r>
-            <a:endParaRPr sz="1350" b="0" i="0">
+            <a:endParaRPr sz="2400" b="0" i="0">
               <a:solidFill>
                 <a:srgbClr val="1F2A37"/>
               </a:solidFill>
@@ -9299,191 +7947,6 @@
           </a:p>
         </p:txBody>
       </p:sp>
-      <p:sp>
-        <p:nvSpPr>
-          <p:cNvPr id="5" name="close.authorities"/>
-          <p:cNvSpPr>
-            <a:spLocks noGrp="1"/>
-          </p:cNvSpPr>
-          <p:nvPr>
-            <p:ph type="body" idx="12"/>
-          </p:nvPr>
-        </p:nvSpPr>
-        <p:spPr/>
-        <p:txBody>
-          <a:bodyPr/>
-          <a:lstStyle/>
-          <a:p>
-            <a:r>
-              <a:rPr sz="900" b="1" i="0" spc="60">
-                <a:solidFill>
-                  <a:srgbClr val="0271CE"/>
-                </a:solidFill>
-                <a:latin typeface="Calibri"/>
-              </a:rPr>
-              <a:t>EXTERNAL AUTHORITIES</a:t>
-            </a:r>
-            <a:endParaRPr sz="1000" b="0" i="0">
-              <a:solidFill>
-                <a:srgbClr val="1F2A37"/>
-              </a:solidFill>
-              <a:latin typeface="Calibri"/>
-            </a:endParaRPr>
-          </a:p>
-          <a:p>
-            <a:r>
-              <a:rPr sz="1000" b="0" i="0">
-                <a:solidFill>
-                  <a:srgbClr val="1F2A37"/>
-                </a:solidFill>
-                <a:latin typeface="Calibri"/>
-              </a:rPr>
-              <a:t>Title VII of the Civil Rights Act — sex-based harassment, including conduct based on gender stereotypes, as sex discrimination.</a:t>
-            </a:r>
-            <a:endParaRPr sz="1000" b="0" i="0">
-              <a:solidFill>
-                <a:srgbClr val="1F2A37"/>
-              </a:solidFill>
-              <a:latin typeface="Calibri"/>
-            </a:endParaRPr>
-          </a:p>
-        </p:txBody>
-      </p:sp>
-      <p:sp>
-        <p:nvSpPr>
-          <p:cNvPr id="6" name="close.internal"/>
-          <p:cNvSpPr>
-            <a:spLocks noGrp="1"/>
-          </p:cNvSpPr>
-          <p:nvPr>
-            <p:ph type="body" idx="13"/>
-          </p:nvPr>
-        </p:nvSpPr>
-        <p:spPr/>
-        <p:txBody>
-          <a:bodyPr/>
-          <a:lstStyle/>
-          <a:p>
-            <a:r>
-              <a:rPr sz="900" b="1" i="0" spc="60">
-                <a:solidFill>
-                  <a:srgbClr val="0271CE"/>
-                </a:solidFill>
-                <a:latin typeface="Calibri"/>
-              </a:rPr>
-              <a:t>INTERNAL SOURCE SLIDES</a:t>
-            </a:r>
-            <a:endParaRPr sz="1000" b="0" i="0">
-              <a:solidFill>
-                <a:srgbClr val="1F2A37"/>
-              </a:solidFill>
-              <a:latin typeface="Calibri"/>
-            </a:endParaRPr>
-          </a:p>
-          <a:p>
-            <a:r>
-              <a:rPr sz="1000" b="0" i="0">
-                <a:solidFill>
-                  <a:srgbClr val="1F2A37"/>
-                </a:solidFill>
-                <a:latin typeface="Calibri"/>
-              </a:rPr>
-              <a:t>Slide 19 — scenario narration</a:t>
-            </a:r>
-            <a:endParaRPr sz="1000" b="0" i="0">
-              <a:solidFill>
-                <a:srgbClr val="1F2A37"/>
-              </a:solidFill>
-              <a:latin typeface="Calibri"/>
-            </a:endParaRPr>
-          </a:p>
-          <a:p>
-            <a:r>
-              <a:rPr sz="1000" b="0" i="0">
-                <a:solidFill>
-                  <a:srgbClr val="1F2A37"/>
-                </a:solidFill>
-                <a:latin typeface="Calibri"/>
-              </a:rPr>
-              <a:t>Slide 20 — knowledge check: should Marshall report?</a:t>
-            </a:r>
-            <a:endParaRPr sz="1000" b="0" i="0">
-              <a:solidFill>
-                <a:srgbClr val="1F2A37"/>
-              </a:solidFill>
-              <a:latin typeface="Calibri"/>
-            </a:endParaRPr>
-          </a:p>
-          <a:p>
-            <a:r>
-              <a:rPr sz="1000" b="0" i="0">
-                <a:solidFill>
-                  <a:srgbClr val="1F2A37"/>
-                </a:solidFill>
-                <a:latin typeface="Calibri"/>
-              </a:rPr>
-              <a:t>Slide 21 — Marshall’s real case</a:t>
-            </a:r>
-            <a:endParaRPr sz="1000" b="0" i="0">
-              <a:solidFill>
-                <a:srgbClr val="1F2A37"/>
-              </a:solidFill>
-              <a:latin typeface="Calibri"/>
-            </a:endParaRPr>
-          </a:p>
-          <a:p>
-            <a:r>
-              <a:rPr sz="1000" b="0" i="0">
-                <a:solidFill>
-                  <a:srgbClr val="1F2A37"/>
-                </a:solidFill>
-                <a:latin typeface="Calibri"/>
-              </a:rPr>
-              <a:t>Slide 24 — hostile work environment definition</a:t>
-            </a:r>
-            <a:endParaRPr sz="1000" b="0" i="0">
-              <a:solidFill>
-                <a:srgbClr val="1F2A37"/>
-              </a:solidFill>
-              <a:latin typeface="Calibri"/>
-            </a:endParaRPr>
-          </a:p>
-          <a:p>
-            <a:r>
-              <a:rPr sz="1000" b="0" i="0">
-                <a:solidFill>
-                  <a:srgbClr val="1F2A37"/>
-                </a:solidFill>
-                <a:latin typeface="Calibri"/>
-              </a:rPr>
-              <a:t>Slide 13 — Title VII foundation</a:t>
-            </a:r>
-            <a:endParaRPr sz="1000" b="0" i="0">
-              <a:solidFill>
-                <a:srgbClr val="1F2A37"/>
-              </a:solidFill>
-              <a:latin typeface="Calibri"/>
-            </a:endParaRPr>
-          </a:p>
-          <a:p>
-            <a:r>
-              <a:rPr sz="1000" b="0" i="0">
-                <a:solidFill>
-                  <a:srgbClr val="1F2A37"/>
-                </a:solidFill>
-                <a:latin typeface="Calibri"/>
-              </a:rPr>
-              <a:t>Slides 40–41 — bystander guidance</a:t>
-            </a:r>
-            <a:endParaRPr sz="1000" b="0" i="0">
-              <a:solidFill>
-                <a:srgbClr val="1F2A37"/>
-              </a:solidFill>
-              <a:latin typeface="Calibri"/>
-            </a:endParaRPr>
-          </a:p>
-        </p:txBody>
-      </p:sp>
     </p:spTree>
   </p:cSld>
   <p:clrMapOvr>
@@ -9629,191 +8092,6 @@
           </a:p>
         </p:txBody>
       </p:sp>
-      <p:sp>
-        <p:nvSpPr>
-          <p:cNvPr id="5" name="brief.steps"/>
-          <p:cNvSpPr>
-            <a:spLocks noGrp="1"/>
-          </p:cNvSpPr>
-          <p:nvPr>
-            <p:ph type="body" idx="12"/>
-          </p:nvPr>
-        </p:nvSpPr>
-        <p:spPr/>
-        <p:txBody>
-          <a:bodyPr/>
-          <a:lstStyle/>
-          <a:p>
-            <a:r>
-              <a:rPr sz="900" b="1" i="0" spc="60">
-                <a:solidFill>
-                  <a:srgbClr val="0271CE"/>
-                </a:solidFill>
-                <a:latin typeface="Calibri"/>
-              </a:rPr>
-              <a:t>STEPS, IN ORDER — ONE PER LINE, EACH STARTING WITH ITS MODE</a:t>
-            </a:r>
-            <a:endParaRPr sz="1200" b="0" i="0">
-              <a:solidFill>
-                <a:srgbClr val="1F2A37"/>
-              </a:solidFill>
-              <a:latin typeface="Calibri"/>
-            </a:endParaRPr>
-          </a:p>
-          <a:p>
-            <a:r>
-              <a:rPr sz="1200" b="0" i="0">
-                <a:solidFill>
-                  <a:srgbClr val="1F2A37"/>
-                </a:solidFill>
-                <a:latin typeface="Calibri"/>
-              </a:rPr>
-              <a:t>coach: Does this qualify as harassment? Reason it through under Title VII — there is a right answer, and it is yes.</a:t>
-            </a:r>
-            <a:endParaRPr sz="1200" b="0" i="0">
-              <a:solidFill>
-                <a:srgbClr val="1F2A37"/>
-              </a:solidFill>
-              <a:latin typeface="Calibri"/>
-            </a:endParaRPr>
-          </a:p>
-          <a:p>
-            <a:r>
-              <a:rPr sz="1200" b="0" i="0">
-                <a:solidFill>
-                  <a:srgbClr val="1F2A37"/>
-                </a:solidFill>
-                <a:latin typeface="Calibri"/>
-              </a:rPr>
-              <a:t>coach: What is Marshall experiencing? Set the law aside — the personal, professional and team-wide impact.</a:t>
-            </a:r>
-            <a:endParaRPr sz="1200" b="0" i="0">
-              <a:solidFill>
-                <a:srgbClr val="1F2A37"/>
-              </a:solidFill>
-              <a:latin typeface="Calibri"/>
-            </a:endParaRPr>
-          </a:p>
-          <a:p>
-            <a:r>
-              <a:rPr sz="1200" b="0" i="0">
-                <a:solidFill>
-                  <a:srgbClr val="1F2A37"/>
-                </a:solidFill>
-                <a:latin typeface="Calibri"/>
-              </a:rPr>
-              <a:t>roleplay: The break room — Jake makes a ‘Marsha’ comment with the room watching, and the learner has to act.</a:t>
-            </a:r>
-            <a:endParaRPr sz="1200" b="0" i="0">
-              <a:solidFill>
-                <a:srgbClr val="1F2A37"/>
-              </a:solidFill>
-              <a:latin typeface="Calibri"/>
-            </a:endParaRPr>
-          </a:p>
-        </p:txBody>
-      </p:sp>
-      <p:sp>
-        <p:nvSpPr>
-          <p:cNvPr id="6" name="brief.sources"/>
-          <p:cNvSpPr>
-            <a:spLocks noGrp="1"/>
-          </p:cNvSpPr>
-          <p:nvPr>
-            <p:ph type="body" idx="13"/>
-          </p:nvPr>
-        </p:nvSpPr>
-        <p:spPr/>
-        <p:txBody>
-          <a:bodyPr/>
-          <a:lstStyle/>
-          <a:p>
-            <a:r>
-              <a:rPr sz="900" b="1" i="0" spc="60">
-                <a:solidFill>
-                  <a:srgbClr val="0271CE"/>
-                </a:solidFill>
-                <a:latin typeface="Calibri"/>
-              </a:rPr>
-              <a:t>SOURCE SLIDES OR DOCUMENTS</a:t>
-            </a:r>
-            <a:endParaRPr sz="1200" b="0" i="0">
-              <a:solidFill>
-                <a:srgbClr val="1F2A37"/>
-              </a:solidFill>
-              <a:latin typeface="Calibri"/>
-            </a:endParaRPr>
-          </a:p>
-          <a:p>
-            <a:r>
-              <a:rPr sz="1200" b="0" i="0">
-                <a:solidFill>
-                  <a:srgbClr val="1F2A37"/>
-                </a:solidFill>
-                <a:latin typeface="Calibri"/>
-              </a:rPr>
-              <a:t>JCOM-40198 Harassment Prevention for Employees Base Course.pptx</a:t>
-            </a:r>
-            <a:endParaRPr sz="1200" b="0" i="0">
-              <a:solidFill>
-                <a:srgbClr val="1F2A37"/>
-              </a:solidFill>
-              <a:latin typeface="Calibri"/>
-            </a:endParaRPr>
-          </a:p>
-          <a:p>
-            <a:r>
-              <a:rPr sz="1200" b="0" i="0">
-                <a:solidFill>
-                  <a:srgbClr val="1F2A37"/>
-                </a:solidFill>
-                <a:latin typeface="Calibri"/>
-              </a:rPr>
-              <a:t>Slides 18–24 (the Marshall learning object)</a:t>
-            </a:r>
-            <a:endParaRPr sz="1200" b="0" i="0">
-              <a:solidFill>
-                <a:srgbClr val="1F2A37"/>
-              </a:solidFill>
-              <a:latin typeface="Calibri"/>
-            </a:endParaRPr>
-          </a:p>
-          <a:p>
-            <a:r>
-              <a:rPr sz="1200" b="0" i="0">
-                <a:solidFill>
-                  <a:srgbClr val="1F2A37"/>
-                </a:solidFill>
-                <a:latin typeface="Calibri"/>
-              </a:rPr>
-              <a:t>Slide 13 (Title VII foundation)</a:t>
-            </a:r>
-            <a:endParaRPr sz="1200" b="0" i="0">
-              <a:solidFill>
-                <a:srgbClr val="1F2A37"/>
-              </a:solidFill>
-              <a:latin typeface="Calibri"/>
-            </a:endParaRPr>
-          </a:p>
-          <a:p>
-            <a:r>
-              <a:rPr sz="1200" b="0" i="0">
-                <a:solidFill>
-                  <a:srgbClr val="1F2A37"/>
-                </a:solidFill>
-                <a:latin typeface="Calibri"/>
-              </a:rPr>
-              <a:t>Slides 40–41 (Ira knowledge check — bystander guidance)</a:t>
-            </a:r>
-            <a:endParaRPr sz="1200" b="0" i="0">
-              <a:solidFill>
-                <a:srgbClr val="1F2A37"/>
-              </a:solidFill>
-              <a:latin typeface="Calibri"/>
-            </a:endParaRPr>
-          </a:p>
-        </p:txBody>
-      </p:sp>
     </p:spTree>
   </p:cSld>
   <p:clrMapOvr>
@@ -10224,7 +8502,7 @@
                 </a:solidFill>
                 <a:latin typeface="Calibri"/>
               </a:rPr>
-              <a:t>THE TEACHING</a:t>
+              <a:t>CORE TOPICS</a:t>
             </a:r>
           </a:p>
         </p:txBody>
@@ -10251,18 +8529,18 @@
                 </a:solidFill>
                 <a:latin typeface="Calibri"/>
               </a:rPr>
-              <a:t>MUST-KNOWS — 3 TO 6, ONE PER LINE</a:t>
-            </a:r>
-            <a:endParaRPr sz="1050" b="0" i="0">
-              <a:solidFill>
-                <a:srgbClr val="1F2A37"/>
-              </a:solidFill>
-              <a:latin typeface="Calibri"/>
-            </a:endParaRPr>
-          </a:p>
-          <a:p>
-            <a:r>
-              <a:rPr sz="1050" b="0" i="0">
+              <a:t>MUST-KNOWS — ONE PER LINE</a:t>
+            </a:r>
+            <a:endParaRPr sz="1200" b="0" i="0">
+              <a:solidFill>
+                <a:srgbClr val="1F2A37"/>
+              </a:solidFill>
+              <a:latin typeface="Calibri"/>
+            </a:endParaRPr>
+          </a:p>
+          <a:p>
+            <a:r>
+              <a:rPr sz="1200" b="0" i="0">
                 <a:solidFill>
                   <a:srgbClr val="1F2A37"/>
                 </a:solidFill>
@@ -10270,16 +8548,16 @@
               </a:rPr>
               <a:t>Gender-stereotype-based conduct is sex-based harassment under Title VII — no explicit sexual advance or quid pro quo required.</a:t>
             </a:r>
-            <a:endParaRPr sz="1050" b="0" i="0">
-              <a:solidFill>
-                <a:srgbClr val="1F2A37"/>
-              </a:solidFill>
-              <a:latin typeface="Calibri"/>
-            </a:endParaRPr>
-          </a:p>
-          <a:p>
-            <a:r>
-              <a:rPr sz="1050" b="0" i="0">
+            <a:endParaRPr sz="1200" b="0" i="0">
+              <a:solidFill>
+                <a:srgbClr val="1F2A37"/>
+              </a:solidFill>
+              <a:latin typeface="Calibri"/>
+            </a:endParaRPr>
+          </a:p>
+          <a:p>
+            <a:r>
+              <a:rPr sz="1200" b="0" i="0">
                 <a:solidFill>
                   <a:srgbClr val="1F2A37"/>
                 </a:solidFill>
@@ -10287,16 +8565,16 @@
               </a:rPr>
               <a:t>Hostile work environment: pervasive gender-based conduct that makes the workplace intimidating qualifies, and it affects everyone present, not only the target.</a:t>
             </a:r>
-            <a:endParaRPr sz="1050" b="0" i="0">
-              <a:solidFill>
-                <a:srgbClr val="1F2A37"/>
-              </a:solidFill>
-              <a:latin typeface="Calibri"/>
-            </a:endParaRPr>
-          </a:p>
-          <a:p>
-            <a:r>
-              <a:rPr sz="1050" b="0" i="0">
+            <a:endParaRPr sz="1200" b="0" i="0">
+              <a:solidFill>
+                <a:srgbClr val="1F2A37"/>
+              </a:solidFill>
+              <a:latin typeface="Calibri"/>
+            </a:endParaRPr>
+          </a:p>
+          <a:p>
+            <a:r>
+              <a:rPr sz="1200" b="0" i="0">
                 <a:solidFill>
                   <a:srgbClr val="1F2A37"/>
                 </a:solidFill>
@@ -10304,16 +8582,16 @@
               </a:rPr>
               <a:t>Same-sex harassment is fully covered, and intent doesn’t matter — the test is impact and context.</a:t>
             </a:r>
-            <a:endParaRPr sz="1050" b="0" i="0">
-              <a:solidFill>
-                <a:srgbClr val="1F2A37"/>
-              </a:solidFill>
-              <a:latin typeface="Calibri"/>
-            </a:endParaRPr>
-          </a:p>
-          <a:p>
-            <a:r>
-              <a:rPr sz="1050" b="0" i="0">
+            <a:endParaRPr sz="1200" b="0" i="0">
+              <a:solidFill>
+                <a:srgbClr val="1F2A37"/>
+              </a:solidFill>
+              <a:latin typeface="Calibri"/>
+            </a:endParaRPr>
+          </a:p>
+          <a:p>
+            <a:r>
+              <a:rPr sz="1200" b="0" i="0">
                 <a:solidFill>
                   <a:srgbClr val="1F2A37"/>
                 </a:solidFill>
@@ -10321,16 +8599,16 @@
               </a:rPr>
               <a:t>Sustained harassment causes documented psychological and career harm. ‘Just jokes’ is never an accurate frame.</a:t>
             </a:r>
-            <a:endParaRPr sz="1050" b="0" i="0">
-              <a:solidFill>
-                <a:srgbClr val="1F2A37"/>
-              </a:solidFill>
-              <a:latin typeface="Calibri"/>
-            </a:endParaRPr>
-          </a:p>
-          <a:p>
-            <a:r>
-              <a:rPr sz="1050" b="0" i="0">
+            <a:endParaRPr sz="1200" b="0" i="0">
+              <a:solidFill>
+                <a:srgbClr val="1F2A37"/>
+              </a:solidFill>
+              <a:latin typeface="Calibri"/>
+            </a:endParaRPr>
+          </a:p>
+          <a:p>
+            <a:r>
+              <a:rPr sz="1200" b="0" i="0">
                 <a:solidFill>
                   <a:srgbClr val="1F2A37"/>
                 </a:solidFill>
@@ -10338,16 +8616,16 @@
               </a:rPr>
               <a:t>Marshall should report immediately — with documentation of incidents, dates and witnesses.</a:t>
             </a:r>
-            <a:endParaRPr sz="1050" b="0" i="0">
-              <a:solidFill>
-                <a:srgbClr val="1F2A37"/>
-              </a:solidFill>
-              <a:latin typeface="Calibri"/>
-            </a:endParaRPr>
-          </a:p>
-          <a:p>
-            <a:r>
-              <a:rPr sz="1050" b="0" i="0">
+            <a:endParaRPr sz="1200" b="0" i="0">
+              <a:solidFill>
+                <a:srgbClr val="1F2A37"/>
+              </a:solidFill>
+              <a:latin typeface="Calibri"/>
+            </a:endParaRPr>
+          </a:p>
+          <a:p>
+            <a:r>
+              <a:rPr sz="1200" b="0" i="0">
                 <a:solidFill>
                   <a:srgbClr val="1F2A37"/>
                 </a:solidFill>
@@ -10355,7 +8633,7 @@
               </a:rPr>
               <a:t>Bystanders: Pick an Action · Offer Support · Consider Escalating — and check the organization’s policy for witness obligations.</a:t>
             </a:r>
-            <a:endParaRPr sz="1050" b="0" i="0">
+            <a:endParaRPr sz="1200" b="0" i="0">
               <a:solidFill>
                 <a:srgbClr val="1F2A37"/>
               </a:solidFill>
@@ -10388,16 +8666,16 @@
               </a:rPr>
               <a:t>STRONG HANDLING VS. WEAK</a:t>
             </a:r>
-            <a:endParaRPr sz="1200" b="0" i="0">
-              <a:solidFill>
-                <a:srgbClr val="1F2A37"/>
-              </a:solidFill>
-              <a:latin typeface="Calibri"/>
-            </a:endParaRPr>
-          </a:p>
-          <a:p>
-            <a:r>
-              <a:rPr sz="1200" b="0" i="0">
+            <a:endParaRPr sz="1000" b="0" i="0">
+              <a:solidFill>
+                <a:srgbClr val="1F2A37"/>
+              </a:solidFill>
+              <a:latin typeface="Calibri"/>
+            </a:endParaRPr>
+          </a:p>
+          <a:p>
+            <a:r>
+              <a:rPr sz="1000" b="0" i="0">
                 <a:solidFill>
                   <a:srgbClr val="1F2A37"/>
                 </a:solidFill>
@@ -10405,24 +8683,24 @@
               </a:rPr>
               <a:t>Strong: names the gender-stereotype basis, applies the hostile-work-environment standard, arrives at reporting. In the break room, gives a clear direct or indirect signal, checks in with Marshall afterward, and considers escalating per policy.</a:t>
             </a:r>
-            <a:endParaRPr sz="1200" b="0" i="0">
-              <a:solidFill>
-                <a:srgbClr val="1F2A37"/>
-              </a:solidFill>
-              <a:latin typeface="Calibri"/>
-            </a:endParaRPr>
-          </a:p>
-          <a:p>
-            <a:endParaRPr sz="1200" b="0" i="0">
-              <a:solidFill>
-                <a:srgbClr val="1F2A37"/>
-              </a:solidFill>
-              <a:latin typeface="Calibri"/>
-            </a:endParaRPr>
-          </a:p>
-          <a:p>
-            <a:r>
-              <a:rPr sz="1200" b="0" i="0">
+            <a:endParaRPr sz="1000" b="0" i="0">
+              <a:solidFill>
+                <a:srgbClr val="1F2A37"/>
+              </a:solidFill>
+              <a:latin typeface="Calibri"/>
+            </a:endParaRPr>
+          </a:p>
+          <a:p>
+            <a:endParaRPr sz="1000" b="0" i="0">
+              <a:solidFill>
+                <a:srgbClr val="1F2A37"/>
+              </a:solidFill>
+              <a:latin typeface="Calibri"/>
+            </a:endParaRPr>
+          </a:p>
+          <a:p>
+            <a:r>
+              <a:rPr sz="1000" b="0" i="0">
                 <a:solidFill>
                   <a:srgbClr val="1F2A37"/>
                 </a:solidFill>
@@ -10430,7 +8708,7 @@
               </a:rPr>
               <a:t>Weak: ‘not sexual, so not harassment’; ‘just banter’; ‘not my place.’ In the room: silence, laughing along, or putting the onus on Marshall to stand up for himself.</a:t>
             </a:r>
-            <a:endParaRPr sz="1200" b="0" i="0">
+            <a:endParaRPr sz="1000" b="0" i="0">
               <a:solidFill>
                 <a:srgbClr val="1F2A37"/>
               </a:solidFill>
@@ -10647,7 +8925,7 @@
                 </a:solidFill>
                 <a:latin typeface="Calibri"/>
               </a:rPr>
-              <a:t>THE OPENING</a:t>
+              <a:t>INITIAL REFLECTION</a:t>
             </a:r>
           </a:p>
         </p:txBody>
@@ -10774,7 +9052,7 @@
                 </a:solidFill>
                 <a:latin typeface="Calibri"/>
               </a:rPr>
-              <a:t>LISTEN FOR — AND HOW TO ACKNOWLEDGE IT</a:t>
+              <a:t>LISTEN FOR</a:t>
             </a:r>
             <a:endParaRPr sz="1200" b="0" i="0">
               <a:solidFill>
@@ -10936,7 +9214,7 @@
                 </a:solidFill>
                 <a:latin typeface="Calibri"/>
               </a:rPr>
-              <a:t>RIGHT ANSWER?</a:t>
+              <a:t>IS THERE A RIGHT ANSWER?</a:t>
             </a:r>
             <a:endParaRPr sz="800" b="0" i="0">
               <a:solidFill>
@@ -11136,7 +9414,7 @@
                 </a:solidFill>
                 <a:latin typeface="Calibri"/>
               </a:rPr>
-              <a:t>UNTHOUGHTFUL</a:t>
+              <a:t>RESPONSE: UNTHOUGHTFUL</a:t>
             </a:r>
             <a:endParaRPr sz="800" b="0" i="0">
               <a:solidFill>
@@ -11277,7 +9555,7 @@
                 </a:solidFill>
                 <a:latin typeface="Calibri"/>
               </a:rPr>
-              <a:t>NEUTRAL</a:t>
+              <a:t>RESPONSE: NEUTRAL</a:t>
             </a:r>
             <a:endParaRPr sz="850" b="0" i="0">
               <a:solidFill>
@@ -11418,7 +9696,7 @@
                 </a:solidFill>
                 <a:latin typeface="Calibri"/>
               </a:rPr>
-              <a:t>STRONG</a:t>
+              <a:t>RESPONSE: STRONG</a:t>
             </a:r>
             <a:endParaRPr sz="850" b="0" i="0">
               <a:solidFill>
@@ -11559,7 +9837,7 @@
                 </a:solidFill>
                 <a:latin typeface="Calibri"/>
               </a:rPr>
-              <a:t>DEBRIEF LANDS — 2 TO 4 POINTS EVERY LEARNER HEARS, HOWEVER THE ATTEMPT WENT</a:t>
+              <a:t>DEBRIEF — 2 TO 4 POINTS EVERY LEARNER HEARS, HOWEVER THE ATTEMPT WENT</a:t>
             </a:r>
             <a:endParaRPr sz="950" b="0" i="0">
               <a:solidFill>
@@ -11704,7 +9982,7 @@
                 </a:solidFill>
                 <a:latin typeface="Calibri"/>
               </a:rPr>
-              <a:t>RIGHT ANSWER?</a:t>
+              <a:t>IS THERE A RIGHT ANSWER?</a:t>
             </a:r>
             <a:endParaRPr sz="800" b="0" i="0">
               <a:solidFill>
@@ -11904,7 +10182,7 @@
                 </a:solidFill>
                 <a:latin typeface="Calibri"/>
               </a:rPr>
-              <a:t>UNTHOUGHTFUL</a:t>
+              <a:t>RESPONSE: UNTHOUGHTFUL</a:t>
             </a:r>
             <a:endParaRPr sz="850" b="0" i="0">
               <a:solidFill>
@@ -12045,7 +10323,7 @@
                 </a:solidFill>
                 <a:latin typeface="Calibri"/>
               </a:rPr>
-              <a:t>NEUTRAL</a:t>
+              <a:t>RESPONSE: NEUTRAL</a:t>
             </a:r>
             <a:endParaRPr sz="900" b="0" i="0">
               <a:solidFill>
@@ -12186,7 +10464,7 @@
                 </a:solidFill>
                 <a:latin typeface="Calibri"/>
               </a:rPr>
-              <a:t>STRONG</a:t>
+              <a:t>RESPONSE: STRONG</a:t>
             </a:r>
             <a:endParaRPr sz="850" b="0" i="0">
               <a:solidFill>
@@ -12327,7 +10605,7 @@
                 </a:solidFill>
                 <a:latin typeface="Calibri"/>
               </a:rPr>
-              <a:t>DEBRIEF LANDS — 2 TO 4 POINTS EVERY LEARNER HEARS, HOWEVER THE ATTEMPT WENT</a:t>
+              <a:t>DEBRIEF — 2 TO 4 POINTS EVERY LEARNER HEARS, HOWEVER THE ATTEMPT WENT</a:t>
             </a:r>
             <a:endParaRPr sz="950" b="0" i="0">
               <a:solidFill>
@@ -12472,7 +10750,7 @@
                 </a:solidFill>
                 <a:latin typeface="Calibri"/>
               </a:rPr>
-              <a:t>RIGHT ANSWER?</a:t>
+              <a:t>IS THERE A RIGHT ANSWER?</a:t>
             </a:r>
             <a:endParaRPr sz="800" b="0" i="0">
               <a:solidFill>
@@ -12706,7 +10984,7 @@
                 </a:solidFill>
                 <a:latin typeface="Calibri"/>
               </a:rPr>
-              <a:t>UNTHOUGHTFUL</a:t>
+              <a:t>RESPONSE: UNTHOUGHTFUL</a:t>
             </a:r>
             <a:endParaRPr sz="850" b="0" i="0">
               <a:solidFill>
@@ -12856,7 +11134,7 @@
                 </a:solidFill>
                 <a:latin typeface="Calibri"/>
               </a:rPr>
-              <a:t>NEUTRAL</a:t>
+              <a:t>RESPONSE: NEUTRAL</a:t>
             </a:r>
             <a:endParaRPr sz="800" b="0" i="0">
               <a:solidFill>
@@ -13006,7 +11284,7 @@
                 </a:solidFill>
                 <a:latin typeface="Calibri"/>
               </a:rPr>
-              <a:t>STRONG</a:t>
+              <a:t>RESPONSE: STRONG</a:t>
             </a:r>
             <a:endParaRPr sz="800" b="0" i="0">
               <a:solidFill>
@@ -13156,7 +11434,7 @@
                 </a:solidFill>
                 <a:latin typeface="Calibri"/>
               </a:rPr>
-              <a:t>DEBRIEF LANDS — 2 TO 4 POINTS EVERY LEARNER HEARS, HOWEVER THE ATTEMPT WENT</a:t>
+              <a:t>DEBRIEF — 2 TO 4 POINTS EVERY LEARNER HEARS, HOWEVER THE ATTEMPT WENT</a:t>
             </a:r>
             <a:endParaRPr sz="800" b="0" i="0">
               <a:solidFill>
@@ -13251,7 +11529,7 @@
                 </a:solidFill>
                 <a:latin typeface="Calibri"/>
               </a:rPr>
-              <a:t>UNTHOUGHTFUL</a:t>
+              <a:t>EXAMPLE RESPONSE: UNTHOUGHTFUL</a:t>
             </a:r>
             <a:endParaRPr sz="1100" b="0" i="0">
               <a:solidFill>
@@ -13396,7 +11674,7 @@
                 </a:solidFill>
                 <a:latin typeface="Calibri"/>
               </a:rPr>
-              <a:t>NEUTRAL</a:t>
+              <a:t>EXAMPLE RESPONSE: NEUTRAL</a:t>
             </a:r>
             <a:endParaRPr sz="1100" b="0" i="0">
               <a:solidFill>
@@ -13541,7 +11819,7 @@
                 </a:solidFill>
                 <a:latin typeface="Calibri"/>
               </a:rPr>
-              <a:t>STRONG</a:t>
+              <a:t>EXAMPLE RESPONSE: STRONG</a:t>
             </a:r>
             <a:endParaRPr sz="1100" b="0" i="0">
               <a:solidFill>

</xml_diff>